<commit_message>
Update Capítulo III deck with final QA-passed version (34 slides)
The initial commit captured an in-progress version before the deck's
visual QA fixes (table/caption overlaps, stat-callout overflow, balance
fills) completed. This replaces it with the finished 34-slide deck.
</commit_message>
<xml_diff>
--- a/presentaciones/Capitulo_III_Evaluacion_Preanestesica.pptx
+++ b/presentaciones/Capitulo_III_Evaluacion_Preanestesica.pptx
@@ -4000,33 +4000,13 @@
       </p:sp>
       <p:sp>
         <p:nvSpPr>
-          <p:cNvPr id="8" name="Shape 6"/>
-          <p:cNvSpPr/>
-          <p:nvPr/>
-        </p:nvSpPr>
-        <p:spPr>
-          <a:xfrm>
-            <a:off x="841248" y="3977640"/>
-            <a:ext cx="2377440" cy="41148"/>
-          </a:xfrm>
-          <a:prstGeom prst="rect">
-            <a:avLst/>
-          </a:prstGeom>
-          <a:solidFill>
-            <a:srgbClr val="0C4A50"/>
-          </a:solidFill>
-          <a:ln/>
-        </p:spPr>
-      </p:sp>
-      <p:sp>
-        <p:nvSpPr>
-          <p:cNvPr id="9" name="Text 7"/>
+          <p:cNvPr id="8" name="Text 6"/>
           <p:cNvSpPr txBox="1"/>
           <p:nvPr/>
         </p:nvSpPr>
         <p:spPr>
           <a:xfrm>
-            <a:off x="822960" y="4160520"/>
+            <a:off x="822960" y="4114800"/>
             <a:ext cx="7863840" cy="731520"/>
           </a:xfrm>
           <a:prstGeom prst="rect">
@@ -4062,7 +4042,7 @@
       </p:sp>
       <p:sp>
         <p:nvSpPr>
-          <p:cNvPr id="10" name="Shape 8"/>
+          <p:cNvPr id="9" name="Shape 7"/>
           <p:cNvSpPr/>
           <p:nvPr/>
         </p:nvSpPr>
@@ -4082,7 +4062,7 @@
       </p:sp>
       <p:pic>
         <p:nvPicPr>
-          <p:cNvPr id="11" name="Image 0" descr="/tmp/claude-0/-home-user-gpa-academy1/adc6e4aa-3b77-57c1-ba92-a8d4ee625c84/scratchpad/pptx_ch3/icons/clipboard_white.png">    </p:cNvPr>
+          <p:cNvPr id="10" name="Image 0" descr="/tmp/claude-0/-home-user-gpa-academy1/adc6e4aa-3b77-57c1-ba92-a8d4ee625c84/scratchpad/pptx_ch3/icons/clipboard_white.png">    </p:cNvPr>
           <p:cNvPicPr>
             <a:picLocks noChangeAspect="1"/>
           </p:cNvPicPr>
@@ -4106,7 +4086,7 @@
       </p:pic>
       <p:sp>
         <p:nvSpPr>
-          <p:cNvPr id="12" name="Text 9"/>
+          <p:cNvPr id="11" name="Text 8"/>
           <p:cNvSpPr txBox="1"/>
           <p:nvPr/>
         </p:nvSpPr>
@@ -4145,7 +4125,7 @@
       </p:sp>
       <p:sp>
         <p:nvSpPr>
-          <p:cNvPr id="13" name="Text 10"/>
+          <p:cNvPr id="12" name="Text 9"/>
           <p:cNvSpPr txBox="1"/>
           <p:nvPr/>
         </p:nvSpPr>
@@ -7757,12 +7737,12 @@
         </p:nvSpPr>
         <p:spPr>
           <a:xfrm>
-            <a:off x="548640" y="4846320"/>
-            <a:ext cx="3291840" cy="1188720"/>
+            <a:off x="548640" y="4800600"/>
+            <a:ext cx="3291840" cy="1371600"/>
           </a:xfrm>
           <a:prstGeom prst="roundRect">
             <a:avLst>
-              <a:gd name="adj" fmla="val 6154"/>
+              <a:gd name="adj" fmla="val 5333"/>
             </a:avLst>
           </a:prstGeom>
           <a:solidFill>
@@ -7791,8 +7771,8 @@
         </p:nvSpPr>
         <p:spPr>
           <a:xfrm>
-            <a:off x="685800" y="4937760"/>
-            <a:ext cx="3017520" cy="594360"/>
+            <a:off x="685800" y="4892040"/>
+            <a:ext cx="3017520" cy="566928"/>
           </a:xfrm>
           <a:prstGeom prst="rect">
             <a:avLst/>
@@ -7830,8 +7810,8 @@
         </p:nvSpPr>
         <p:spPr>
           <a:xfrm>
-            <a:off x="685800" y="5535778"/>
-            <a:ext cx="3017520" cy="274320"/>
+            <a:off x="685800" y="5513832"/>
+            <a:ext cx="3017520" cy="256032"/>
           </a:xfrm>
           <a:prstGeom prst="rect">
             <a:avLst/>
@@ -7869,8 +7849,8 @@
         </p:nvSpPr>
         <p:spPr>
           <a:xfrm>
-            <a:off x="685800" y="5791810"/>
-            <a:ext cx="3017520" cy="356616"/>
+            <a:off x="685800" y="5788152"/>
+            <a:ext cx="3017520" cy="274320"/>
           </a:xfrm>
           <a:prstGeom prst="rect">
             <a:avLst/>
@@ -7911,12 +7891,12 @@
         </p:nvSpPr>
         <p:spPr>
           <a:xfrm>
-            <a:off x="3977640" y="4846320"/>
-            <a:ext cx="7635240" cy="1188720"/>
+            <a:off x="3977640" y="4800600"/>
+            <a:ext cx="7635240" cy="1371600"/>
           </a:xfrm>
           <a:prstGeom prst="roundRect">
             <a:avLst>
-              <a:gd name="adj" fmla="val 6154"/>
+              <a:gd name="adj" fmla="val 5333"/>
             </a:avLst>
           </a:prstGeom>
           <a:solidFill>
@@ -7933,7 +7913,7 @@
         </p:nvSpPr>
         <p:spPr>
           <a:xfrm>
-            <a:off x="4178808" y="5202936"/>
+            <a:off x="4178808" y="5248656"/>
             <a:ext cx="475488" cy="475488"/>
           </a:xfrm>
           <a:prstGeom prst="ellipse">
@@ -7961,7 +7941,7 @@
         </p:blipFill>
         <p:spPr>
           <a:xfrm>
-            <a:off x="4283415" y="5307543"/>
+            <a:off x="4283415" y="5353263"/>
             <a:ext cx="266273" cy="266273"/>
           </a:xfrm>
           <a:prstGeom prst="rect">
@@ -7977,7 +7957,7 @@
         </p:nvSpPr>
         <p:spPr>
           <a:xfrm>
-            <a:off x="4800600" y="4974336"/>
+            <a:off x="4800600" y="4928616"/>
             <a:ext cx="6629400" cy="256032"/>
           </a:xfrm>
           <a:prstGeom prst="rect">
@@ -8016,8 +7996,8 @@
         </p:nvSpPr>
         <p:spPr>
           <a:xfrm>
-            <a:off x="4800600" y="5248656"/>
-            <a:ext cx="6629400" cy="685800"/>
+            <a:off x="4800600" y="5202936"/>
+            <a:ext cx="6629400" cy="868680"/>
           </a:xfrm>
           <a:prstGeom prst="rect">
             <a:avLst/>
@@ -8294,7 +8274,7 @@
         <p:spPr>
           <a:xfrm>
             <a:off x="548640" y="1572768"/>
-            <a:ext cx="7315200" cy="274320"/>
+            <a:ext cx="6766560" cy="274320"/>
           </a:xfrm>
           <a:prstGeom prst="rect">
             <a:avLst/>
@@ -8310,7 +8290,7 @@
               <a:buNone/>
             </a:pPr>
             <a:r>
-              <a:rPr lang="en-US" sz="1300" b="1" spc="50" kern="0" dirty="0">
+              <a:rPr lang="en-US" sz="1200" b="1" spc="50" kern="0" dirty="0">
                 <a:solidFill>
                   <a:srgbClr val="028090"/>
                 </a:solidFill>
@@ -8318,9 +8298,9 @@
                 <a:ea typeface="Calibri" pitchFamily="34" charset="-122"/>
                 <a:cs typeface="Calibri" pitchFamily="34" charset="-120"/>
               </a:rPr>
-              <a:t>CUESTIONARIO CAGE — TAMIZAJE RÁPIDO DE CONSUMO PROBLEMÁTICO</a:t>
-            </a:r>
-            <a:endParaRPr lang="en-US" sz="1300" dirty="0"/>
+              <a:t>CUESTIONARIO CAGE: TAMIZAJE RÁPIDO DE CONSUMO PROBLEMÁTICO</a:t>
+            </a:r>
+            <a:endParaRPr lang="en-US" sz="1200" dirty="0"/>
           </a:p>
         </p:txBody>
       </p:sp>
@@ -8956,12 +8936,12 @@
         </p:nvSpPr>
         <p:spPr>
           <a:xfrm>
-            <a:off x="7406640" y="1572768"/>
-            <a:ext cx="4206240" cy="4434840"/>
+            <a:off x="548640" y="4572000"/>
+            <a:ext cx="6583680" cy="1417320"/>
           </a:xfrm>
           <a:prstGeom prst="roundRect">
             <a:avLst>
-              <a:gd name="adj" fmla="val 1739"/>
+              <a:gd name="adj" fmla="val 5161"/>
             </a:avLst>
           </a:prstGeom>
           <a:solidFill>
@@ -8990,8 +8970,8 @@
         </p:nvSpPr>
         <p:spPr>
           <a:xfrm>
-            <a:off x="7635240" y="1755648"/>
-            <a:ext cx="3749040" cy="320040"/>
+            <a:off x="685800" y="4663440"/>
+            <a:ext cx="6309360" cy="566928"/>
           </a:xfrm>
           <a:prstGeom prst="rect">
             <a:avLst/>
@@ -9000,21 +8980,175 @@
           <a:ln/>
         </p:spPr>
         <p:txBody>
-          <a:bodyPr wrap="square" lIns="0" tIns="0" rIns="0" bIns="0" rtlCol="0" anchor="ctr"/>
-          <a:lstStyle/>
-          <a:p>
-            <a:pPr indent="0" marL="0">
+          <a:bodyPr wrap="square" lIns="0" tIns="0" rIns="0" bIns="0" rtlCol="0" anchor="b"/>
+          <a:lstStyle/>
+          <a:p>
+            <a:pPr algn="ctr" indent="0" marL="0">
               <a:buNone/>
             </a:pPr>
             <a:r>
-              <a:rPr lang="en-US" sz="1400" b="1" dirty="0">
-                <a:solidFill>
-                  <a:srgbClr val="013A40"/>
+              <a:rPr lang="en-US" sz="3400" b="1" dirty="0">
+                <a:solidFill>
+                  <a:srgbClr val="00A896"/>
                 </a:solidFill>
                 <a:latin typeface="Cambria" pitchFamily="34" charset="0"/>
                 <a:ea typeface="Cambria" pitchFamily="34" charset="-122"/>
                 <a:cs typeface="Cambria" pitchFamily="34" charset="-120"/>
               </a:rPr>
+              <a:t>6-96 h</a:t>
+            </a:r>
+            <a:endParaRPr lang="en-US" sz="3400" dirty="0"/>
+          </a:p>
+        </p:txBody>
+      </p:sp>
+      <p:sp>
+        <p:nvSpPr>
+          <p:cNvPr id="11" name="Text 7"/>
+          <p:cNvSpPr txBox="1"/>
+          <p:nvPr/>
+        </p:nvSpPr>
+        <p:spPr>
+          <a:xfrm>
+            <a:off x="685800" y="5285232"/>
+            <a:ext cx="6309360" cy="256032"/>
+          </a:xfrm>
+          <a:prstGeom prst="rect">
+            <a:avLst/>
+          </a:prstGeom>
+          <a:noFill/>
+          <a:ln/>
+        </p:spPr>
+        <p:txBody>
+          <a:bodyPr wrap="square" lIns="0" tIns="0" rIns="0" bIns="0" rtlCol="0" anchor="ctr"/>
+          <a:lstStyle/>
+          <a:p>
+            <a:pPr algn="ctr" indent="0" marL="0">
+              <a:buNone/>
+            </a:pPr>
+            <a:r>
+              <a:rPr lang="en-US" sz="1150" b="1" dirty="0">
+                <a:solidFill>
+                  <a:srgbClr val="013A40"/>
+                </a:solidFill>
+                <a:latin typeface="Calibri" pitchFamily="34" charset="0"/>
+                <a:ea typeface="Calibri" pitchFamily="34" charset="-122"/>
+                <a:cs typeface="Calibri" pitchFamily="34" charset="-120"/>
+              </a:rPr>
+              <a:t>Ventana de riesgo de abstinencia alcohólica</a:t>
+            </a:r>
+            <a:endParaRPr lang="en-US" sz="1150" dirty="0"/>
+          </a:p>
+        </p:txBody>
+      </p:sp>
+      <p:sp>
+        <p:nvSpPr>
+          <p:cNvPr id="12" name="Text 8"/>
+          <p:cNvSpPr txBox="1"/>
+          <p:nvPr/>
+        </p:nvSpPr>
+        <p:spPr>
+          <a:xfrm>
+            <a:off x="685800" y="5559552"/>
+            <a:ext cx="6309360" cy="301752"/>
+          </a:xfrm>
+          <a:prstGeom prst="rect">
+            <a:avLst/>
+          </a:prstGeom>
+          <a:noFill/>
+          <a:ln/>
+        </p:spPr>
+        <p:txBody>
+          <a:bodyPr wrap="square" lIns="0" tIns="0" rIns="0" bIns="0" rtlCol="0" anchor="t"/>
+          <a:lstStyle/>
+          <a:p>
+            <a:pPr algn="ctr" indent="0" marL="0">
+              <a:lnSpc>
+                <a:spcPct val="105000"/>
+              </a:lnSpc>
+              <a:buNone/>
+            </a:pPr>
+            <a:r>
+              <a:rPr lang="en-US" sz="950" dirty="0">
+                <a:solidFill>
+                  <a:srgbClr val="52696C"/>
+                </a:solidFill>
+                <a:latin typeface="Calibri" pitchFamily="34" charset="0"/>
+                <a:ea typeface="Calibri" pitchFamily="34" charset="-122"/>
+                <a:cs typeface="Calibri" pitchFamily="34" charset="-120"/>
+              </a:rPr>
+              <a:t>Vigilancia estrecha del estado neurológico y autonómico en el postoperatorio de pacientes con consumo crónico significativo</a:t>
+            </a:r>
+            <a:endParaRPr lang="en-US" sz="950" dirty="0"/>
+          </a:p>
+        </p:txBody>
+      </p:sp>
+      <p:sp>
+        <p:nvSpPr>
+          <p:cNvPr id="13" name="Shape 9"/>
+          <p:cNvSpPr/>
+          <p:nvPr/>
+        </p:nvSpPr>
+        <p:spPr>
+          <a:xfrm>
+            <a:off x="7406640" y="1572768"/>
+            <a:ext cx="4206240" cy="4434840"/>
+          </a:xfrm>
+          <a:prstGeom prst="roundRect">
+            <a:avLst>
+              <a:gd name="adj" fmla="val 1739"/>
+            </a:avLst>
+          </a:prstGeom>
+          <a:solidFill>
+            <a:srgbClr val="F5FBFA"/>
+          </a:solidFill>
+          <a:ln w="12700">
+            <a:solidFill>
+              <a:srgbClr val="D9E9E8"/>
+            </a:solidFill>
+            <a:prstDash val="solid"/>
+          </a:ln>
+          <a:effectLst>
+            <a:outerShdw sx="100000" sy="100000" kx="0" ky="0" algn="bl" rotWithShape="0" blurRad="76200" dist="25400" dir="5400000">
+              <a:srgbClr val="1B2E30">
+                <a:alpha val="10000"/>
+              </a:srgbClr>
+            </a:outerShdw>
+          </a:effectLst>
+        </p:spPr>
+      </p:sp>
+      <p:sp>
+        <p:nvSpPr>
+          <p:cNvPr id="14" name="Text 10"/>
+          <p:cNvSpPr txBox="1"/>
+          <p:nvPr/>
+        </p:nvSpPr>
+        <p:spPr>
+          <a:xfrm>
+            <a:off x="7635240" y="1755648"/>
+            <a:ext cx="3749040" cy="320040"/>
+          </a:xfrm>
+          <a:prstGeom prst="rect">
+            <a:avLst/>
+          </a:prstGeom>
+          <a:noFill/>
+          <a:ln/>
+        </p:spPr>
+        <p:txBody>
+          <a:bodyPr wrap="square" lIns="0" tIns="0" rIns="0" bIns="0" rtlCol="0" anchor="ctr"/>
+          <a:lstStyle/>
+          <a:p>
+            <a:pPr indent="0" marL="0">
+              <a:buNone/>
+            </a:pPr>
+            <a:r>
+              <a:rPr lang="en-US" sz="1400" b="1" dirty="0">
+                <a:solidFill>
+                  <a:srgbClr val="013A40"/>
+                </a:solidFill>
+                <a:latin typeface="Cambria" pitchFamily="34" charset="0"/>
+                <a:ea typeface="Cambria" pitchFamily="34" charset="-122"/>
+                <a:cs typeface="Cambria" pitchFamily="34" charset="-120"/>
+              </a:rPr>
               <a:t>Implicaciones anestésicas</a:t>
             </a:r>
             <a:endParaRPr lang="en-US" sz="1400" dirty="0"/>
@@ -9023,7 +9157,7 @@
       </p:sp>
       <p:sp>
         <p:nvSpPr>
-          <p:cNvPr id="11" name="Text 7"/>
+          <p:cNvPr id="15" name="Text 11"/>
           <p:cNvSpPr txBox="1"/>
           <p:nvPr/>
         </p:nvSpPr>
@@ -9147,7 +9281,7 @@
       </p:sp>
       <p:sp>
         <p:nvSpPr>
-          <p:cNvPr id="12" name="Text 8"/>
+          <p:cNvPr id="16" name="Text 12"/>
           <p:cNvSpPr txBox="1"/>
           <p:nvPr/>
         </p:nvSpPr>
@@ -9186,7 +9320,7 @@
       </p:sp>
       <p:sp>
         <p:nvSpPr>
-          <p:cNvPr id="13" name="Text 9"/>
+          <p:cNvPr id="17" name="Text 13"/>
           <p:cNvSpPr txBox="1"/>
           <p:nvPr/>
         </p:nvSpPr>
@@ -15053,7 +15187,7 @@
         </p:nvSpPr>
         <p:spPr>
           <a:xfrm>
-            <a:off x="548640" y="1691640"/>
+            <a:off x="548640" y="1828800"/>
             <a:ext cx="512064" cy="512064"/>
           </a:xfrm>
           <a:prstGeom prst="ellipse">
@@ -15081,7 +15215,7 @@
         </p:blipFill>
         <p:spPr>
           <a:xfrm>
-            <a:off x="663854" y="1806854"/>
+            <a:off x="663854" y="1944014"/>
             <a:ext cx="281635" cy="281635"/>
           </a:xfrm>
           <a:prstGeom prst="rect">
@@ -15097,7 +15231,7 @@
         </p:nvSpPr>
         <p:spPr>
           <a:xfrm>
-            <a:off x="1261872" y="1655064"/>
+            <a:off x="1261872" y="1792224"/>
             <a:ext cx="2807208" cy="256032"/>
           </a:xfrm>
           <a:prstGeom prst="rect">
@@ -15114,7 +15248,7 @@
               <a:buNone/>
             </a:pPr>
             <a:r>
-              <a:rPr lang="en-US" sz="1250" b="1" dirty="0">
+              <a:rPr lang="en-US" sz="1300" b="1" dirty="0">
                 <a:solidFill>
                   <a:srgbClr val="013A40"/>
                 </a:solidFill>
@@ -15124,7 +15258,7 @@
               </a:rPr>
               <a:t>Somatometría</a:t>
             </a:r>
-            <a:endParaRPr lang="en-US" sz="1250" dirty="0"/>
+            <a:endParaRPr lang="en-US" sz="1300" dirty="0"/>
           </a:p>
         </p:txBody>
       </p:sp>
@@ -15136,7 +15270,7 @@
         </p:nvSpPr>
         <p:spPr>
           <a:xfrm>
-            <a:off x="1261872" y="1920240"/>
+            <a:off x="1261872" y="2057400"/>
             <a:ext cx="2807208" cy="822960"/>
           </a:xfrm>
           <a:prstGeom prst="rect">
@@ -15156,7 +15290,7 @@
               <a:buNone/>
             </a:pPr>
             <a:r>
-              <a:rPr lang="en-US" sz="1080" dirty="0">
+              <a:rPr lang="en-US" sz="1130" dirty="0">
                 <a:solidFill>
                   <a:srgbClr val="52696C"/>
                 </a:solidFill>
@@ -15166,7 +15300,7 @@
               </a:rPr>
               <a:t>Peso, talla e índice de masa corporal: base para el cálculo de dosis y la valoración de riesgo de vía aérea difícil y apnea del sueño.</a:t>
             </a:r>
-            <a:endParaRPr lang="en-US" sz="1080" dirty="0"/>
+            <a:endParaRPr lang="en-US" sz="1130" dirty="0"/>
           </a:p>
         </p:txBody>
       </p:sp>
@@ -15178,7 +15312,7 @@
         </p:nvSpPr>
         <p:spPr>
           <a:xfrm>
-            <a:off x="4251960" y="1691640"/>
+            <a:off x="4251960" y="1828800"/>
             <a:ext cx="512064" cy="512064"/>
           </a:xfrm>
           <a:prstGeom prst="ellipse">
@@ -15206,7 +15340,7 @@
         </p:blipFill>
         <p:spPr>
           <a:xfrm>
-            <a:off x="4367174" y="1806854"/>
+            <a:off x="4367174" y="1944014"/>
             <a:ext cx="281635" cy="281635"/>
           </a:xfrm>
           <a:prstGeom prst="rect">
@@ -15222,7 +15356,7 @@
         </p:nvSpPr>
         <p:spPr>
           <a:xfrm>
-            <a:off x="4965192" y="1655064"/>
+            <a:off x="4965192" y="1792224"/>
             <a:ext cx="2807208" cy="256032"/>
           </a:xfrm>
           <a:prstGeom prst="rect">
@@ -15239,7 +15373,7 @@
               <a:buNone/>
             </a:pPr>
             <a:r>
-              <a:rPr lang="en-US" sz="1250" b="1" dirty="0">
+              <a:rPr lang="en-US" sz="1300" b="1" dirty="0">
                 <a:solidFill>
                   <a:srgbClr val="013A40"/>
                 </a:solidFill>
@@ -15249,7 +15383,7 @@
               </a:rPr>
               <a:t>Signos vitales</a:t>
             </a:r>
-            <a:endParaRPr lang="en-US" sz="1250" dirty="0"/>
+            <a:endParaRPr lang="en-US" sz="1300" dirty="0"/>
           </a:p>
         </p:txBody>
       </p:sp>
@@ -15261,7 +15395,7 @@
         </p:nvSpPr>
         <p:spPr>
           <a:xfrm>
-            <a:off x="4965192" y="1920240"/>
+            <a:off x="4965192" y="2057400"/>
             <a:ext cx="2807208" cy="822960"/>
           </a:xfrm>
           <a:prstGeom prst="rect">
@@ -15281,7 +15415,7 @@
               <a:buNone/>
             </a:pPr>
             <a:r>
-              <a:rPr lang="en-US" sz="1080" dirty="0">
+              <a:rPr lang="en-US" sz="1130" dirty="0">
                 <a:solidFill>
                   <a:srgbClr val="52696C"/>
                 </a:solidFill>
@@ -15291,7 +15425,7 @@
               </a:rPr>
               <a:t>Presión arterial, frecuencia cardiaca, frecuencia respiratoria, temperatura y saturación de oxígeno basal.</a:t>
             </a:r>
-            <a:endParaRPr lang="en-US" sz="1080" dirty="0"/>
+            <a:endParaRPr lang="en-US" sz="1130" dirty="0"/>
           </a:p>
         </p:txBody>
       </p:sp>
@@ -15303,7 +15437,7 @@
         </p:nvSpPr>
         <p:spPr>
           <a:xfrm>
-            <a:off x="7955280" y="1691640"/>
+            <a:off x="7955280" y="1828800"/>
             <a:ext cx="512064" cy="512064"/>
           </a:xfrm>
           <a:prstGeom prst="ellipse">
@@ -15331,7 +15465,7 @@
         </p:blipFill>
         <p:spPr>
           <a:xfrm>
-            <a:off x="8070494" y="1806854"/>
+            <a:off x="8070494" y="1944014"/>
             <a:ext cx="281635" cy="281635"/>
           </a:xfrm>
           <a:prstGeom prst="rect">
@@ -15347,7 +15481,7 @@
         </p:nvSpPr>
         <p:spPr>
           <a:xfrm>
-            <a:off x="8668512" y="1655064"/>
+            <a:off x="8668512" y="1792224"/>
             <a:ext cx="2807208" cy="256032"/>
           </a:xfrm>
           <a:prstGeom prst="rect">
@@ -15364,7 +15498,7 @@
               <a:buNone/>
             </a:pPr>
             <a:r>
-              <a:rPr lang="en-US" sz="1250" b="1" dirty="0">
+              <a:rPr lang="en-US" sz="1300" b="1" dirty="0">
                 <a:solidFill>
                   <a:srgbClr val="013A40"/>
                 </a:solidFill>
@@ -15374,7 +15508,7 @@
               </a:rPr>
               <a:t>Inspección general</a:t>
             </a:r>
-            <a:endParaRPr lang="en-US" sz="1250" dirty="0"/>
+            <a:endParaRPr lang="en-US" sz="1300" dirty="0"/>
           </a:p>
         </p:txBody>
       </p:sp>
@@ -15386,7 +15520,7 @@
         </p:nvSpPr>
         <p:spPr>
           <a:xfrm>
-            <a:off x="8668512" y="1920240"/>
+            <a:off x="8668512" y="2057400"/>
             <a:ext cx="2807208" cy="822960"/>
           </a:xfrm>
           <a:prstGeom prst="rect">
@@ -15406,7 +15540,7 @@
               <a:buNone/>
             </a:pPr>
             <a:r>
-              <a:rPr lang="en-US" sz="1080" dirty="0">
+              <a:rPr lang="en-US" sz="1130" dirty="0">
                 <a:solidFill>
                   <a:srgbClr val="52696C"/>
                 </a:solidFill>
@@ -15416,7 +15550,7 @@
               </a:rPr>
               <a:t>Estado nutricional, coloración de piel y mucosas, hidratación, presencia de edema o deformidades.</a:t>
             </a:r>
-            <a:endParaRPr lang="en-US" sz="1080" dirty="0"/>
+            <a:endParaRPr lang="en-US" sz="1130" dirty="0"/>
           </a:p>
         </p:txBody>
       </p:sp>
@@ -15428,7 +15562,7 @@
         </p:nvSpPr>
         <p:spPr>
           <a:xfrm>
-            <a:off x="548640" y="3840480"/>
+            <a:off x="548640" y="4160520"/>
             <a:ext cx="512064" cy="512064"/>
           </a:xfrm>
           <a:prstGeom prst="ellipse">
@@ -15456,7 +15590,7 @@
         </p:blipFill>
         <p:spPr>
           <a:xfrm>
-            <a:off x="663854" y="3955694"/>
+            <a:off x="663854" y="4275734"/>
             <a:ext cx="281635" cy="281635"/>
           </a:xfrm>
           <a:prstGeom prst="rect">
@@ -15472,7 +15606,7 @@
         </p:nvSpPr>
         <p:spPr>
           <a:xfrm>
-            <a:off x="1261872" y="3803904"/>
+            <a:off x="1261872" y="4123944"/>
             <a:ext cx="2807208" cy="256032"/>
           </a:xfrm>
           <a:prstGeom prst="rect">
@@ -15489,7 +15623,7 @@
               <a:buNone/>
             </a:pPr>
             <a:r>
-              <a:rPr lang="en-US" sz="1250" b="1" dirty="0">
+              <a:rPr lang="en-US" sz="1300" b="1" dirty="0">
                 <a:solidFill>
                   <a:srgbClr val="013A40"/>
                 </a:solidFill>
@@ -15499,7 +15633,7 @@
               </a:rPr>
               <a:t>Exploración cardiopulmonar</a:t>
             </a:r>
-            <a:endParaRPr lang="en-US" sz="1250" dirty="0"/>
+            <a:endParaRPr lang="en-US" sz="1300" dirty="0"/>
           </a:p>
         </p:txBody>
       </p:sp>
@@ -15511,7 +15645,7 @@
         </p:nvSpPr>
         <p:spPr>
           <a:xfrm>
-            <a:off x="1261872" y="4069080"/>
+            <a:off x="1261872" y="4389120"/>
             <a:ext cx="2807208" cy="822960"/>
           </a:xfrm>
           <a:prstGeom prst="rect">
@@ -15531,7 +15665,7 @@
               <a:buNone/>
             </a:pPr>
             <a:r>
-              <a:rPr lang="en-US" sz="1080" dirty="0">
+              <a:rPr lang="en-US" sz="1130" dirty="0">
                 <a:solidFill>
                   <a:srgbClr val="52696C"/>
                 </a:solidFill>
@@ -15541,7 +15675,7 @@
               </a:rPr>
               <a:t>Auscultación cardiaca y pulmonar dirigida, en todo paciente independientemente del motivo de consulta.</a:t>
             </a:r>
-            <a:endParaRPr lang="en-US" sz="1080" dirty="0"/>
+            <a:endParaRPr lang="en-US" sz="1130" dirty="0"/>
           </a:p>
         </p:txBody>
       </p:sp>
@@ -15553,7 +15687,7 @@
         </p:nvSpPr>
         <p:spPr>
           <a:xfrm>
-            <a:off x="4251960" y="3840480"/>
+            <a:off x="4251960" y="4160520"/>
             <a:ext cx="512064" cy="512064"/>
           </a:xfrm>
           <a:prstGeom prst="ellipse">
@@ -15581,7 +15715,7 @@
         </p:blipFill>
         <p:spPr>
           <a:xfrm>
-            <a:off x="4367174" y="3955694"/>
+            <a:off x="4367174" y="4275734"/>
             <a:ext cx="281635" cy="281635"/>
           </a:xfrm>
           <a:prstGeom prst="rect">
@@ -15597,7 +15731,7 @@
         </p:nvSpPr>
         <p:spPr>
           <a:xfrm>
-            <a:off x="4965192" y="3803904"/>
+            <a:off x="4965192" y="4123944"/>
             <a:ext cx="2807208" cy="256032"/>
           </a:xfrm>
           <a:prstGeom prst="rect">
@@ -15614,7 +15748,7 @@
               <a:buNone/>
             </a:pPr>
             <a:r>
-              <a:rPr lang="en-US" sz="1250" b="1" dirty="0">
+              <a:rPr lang="en-US" sz="1300" b="1" dirty="0">
                 <a:solidFill>
                   <a:srgbClr val="013A40"/>
                 </a:solidFill>
@@ -15624,7 +15758,7 @@
               </a:rPr>
               <a:t>Sistema musculoesquelético</a:t>
             </a:r>
-            <a:endParaRPr lang="en-US" sz="1250" dirty="0"/>
+            <a:endParaRPr lang="en-US" sz="1300" dirty="0"/>
           </a:p>
         </p:txBody>
       </p:sp>
@@ -15636,7 +15770,7 @@
         </p:nvSpPr>
         <p:spPr>
           <a:xfrm>
-            <a:off x="4965192" y="4069080"/>
+            <a:off x="4965192" y="4389120"/>
             <a:ext cx="2807208" cy="822960"/>
           </a:xfrm>
           <a:prstGeom prst="rect">
@@ -15656,7 +15790,7 @@
               <a:buNone/>
             </a:pPr>
             <a:r>
-              <a:rPr lang="en-US" sz="1080" dirty="0">
+              <a:rPr lang="en-US" sz="1130" dirty="0">
                 <a:solidFill>
                   <a:srgbClr val="52696C"/>
                 </a:solidFill>
@@ -15666,7 +15800,7 @@
               </a:rPr>
               <a:t>Movilidad cervical, columna vertebral (relevante para anestesia regional) y limitaciones de posicionamiento.</a:t>
             </a:r>
-            <a:endParaRPr lang="en-US" sz="1080" dirty="0"/>
+            <a:endParaRPr lang="en-US" sz="1130" dirty="0"/>
           </a:p>
         </p:txBody>
       </p:sp>
@@ -15678,7 +15812,7 @@
         </p:nvSpPr>
         <p:spPr>
           <a:xfrm>
-            <a:off x="7955280" y="3840480"/>
+            <a:off x="7955280" y="4160520"/>
             <a:ext cx="512064" cy="512064"/>
           </a:xfrm>
           <a:prstGeom prst="ellipse">
@@ -15706,7 +15840,7 @@
         </p:blipFill>
         <p:spPr>
           <a:xfrm>
-            <a:off x="8070494" y="3955694"/>
+            <a:off x="8070494" y="4275734"/>
             <a:ext cx="281635" cy="281635"/>
           </a:xfrm>
           <a:prstGeom prst="rect">
@@ -15722,7 +15856,7 @@
         </p:nvSpPr>
         <p:spPr>
           <a:xfrm>
-            <a:off x="8668512" y="3803904"/>
+            <a:off x="8668512" y="4123944"/>
             <a:ext cx="2807208" cy="256032"/>
           </a:xfrm>
           <a:prstGeom prst="rect">
@@ -15739,7 +15873,7 @@
               <a:buNone/>
             </a:pPr>
             <a:r>
-              <a:rPr lang="en-US" sz="1250" b="1" dirty="0">
+              <a:rPr lang="en-US" sz="1300" b="1" dirty="0">
                 <a:solidFill>
                   <a:srgbClr val="013A40"/>
                 </a:solidFill>
@@ -15749,7 +15883,7 @@
               </a:rPr>
               <a:t>Accesos vasculares</a:t>
             </a:r>
-            <a:endParaRPr lang="en-US" sz="1250" dirty="0"/>
+            <a:endParaRPr lang="en-US" sz="1300" dirty="0"/>
           </a:p>
         </p:txBody>
       </p:sp>
@@ -15761,7 +15895,7 @@
         </p:nvSpPr>
         <p:spPr>
           <a:xfrm>
-            <a:off x="8668512" y="4069080"/>
+            <a:off x="8668512" y="4389120"/>
             <a:ext cx="2807208" cy="822960"/>
           </a:xfrm>
           <a:prstGeom prst="rect">
@@ -15781,7 +15915,7 @@
               <a:buNone/>
             </a:pPr>
             <a:r>
-              <a:rPr lang="en-US" sz="1080" dirty="0">
+              <a:rPr lang="en-US" sz="1130" dirty="0">
                 <a:solidFill>
                   <a:srgbClr val="52696C"/>
                 </a:solidFill>
@@ -15791,20 +15925,86 @@
               </a:rPr>
               <a:t>Valoración de venas periféricas y sitios potenciales para catéteres centrales si se anticipan.</a:t>
             </a:r>
-            <a:endParaRPr lang="en-US" sz="1080" dirty="0"/>
-          </a:p>
-        </p:txBody>
-      </p:sp>
-      <p:sp>
-        <p:nvSpPr>
-          <p:cNvPr id="30" name="Text 21"/>
+            <a:endParaRPr lang="en-US" sz="1130" dirty="0"/>
+          </a:p>
+        </p:txBody>
+      </p:sp>
+      <p:sp>
+        <p:nvSpPr>
+          <p:cNvPr id="30" name="Shape 21"/>
+          <p:cNvSpPr/>
+          <p:nvPr/>
+        </p:nvSpPr>
+        <p:spPr>
+          <a:xfrm>
+            <a:off x="548640" y="5577840"/>
+            <a:ext cx="11064240" cy="777240"/>
+          </a:xfrm>
+          <a:prstGeom prst="roundRect">
+            <a:avLst>
+              <a:gd name="adj" fmla="val 9412"/>
+            </a:avLst>
+          </a:prstGeom>
+          <a:solidFill>
+            <a:srgbClr val="EFF7F7"/>
+          </a:solidFill>
+          <a:ln/>
+        </p:spPr>
+      </p:sp>
+      <p:sp>
+        <p:nvSpPr>
+          <p:cNvPr id="31" name="Shape 22"/>
+          <p:cNvSpPr/>
+          <p:nvPr/>
+        </p:nvSpPr>
+        <p:spPr>
+          <a:xfrm>
+            <a:off x="749808" y="5728716"/>
+            <a:ext cx="475488" cy="475488"/>
+          </a:xfrm>
+          <a:prstGeom prst="ellipse">
+            <a:avLst/>
+          </a:prstGeom>
+          <a:solidFill>
+            <a:srgbClr val="028090"/>
+          </a:solidFill>
+          <a:ln/>
+        </p:spPr>
+      </p:sp>
+      <p:pic>
+        <p:nvPicPr>
+          <p:cNvPr id="32" name="Image 7" descr="/tmp/claude-0/-home-user-gpa-academy1/adc6e4aa-3b77-57c1-ba92-a8d4ee625c84/scratchpad/pptx_ch3/icons/checklist_white.png">    </p:cNvPr>
+          <p:cNvPicPr>
+            <a:picLocks noChangeAspect="1"/>
+          </p:cNvPicPr>
+          <p:nvPr/>
+        </p:nvPicPr>
+        <p:blipFill>
+          <a:blip r:embed="rId8"/>
+          <a:stretch>
+            <a:fillRect/>
+          </a:stretch>
+        </p:blipFill>
+        <p:spPr>
+          <a:xfrm>
+            <a:off x="854415" y="5833323"/>
+            <a:ext cx="266273" cy="266273"/>
+          </a:xfrm>
+          <a:prstGeom prst="rect">
+            <a:avLst/>
+          </a:prstGeom>
+        </p:spPr>
+      </p:pic>
+      <p:sp>
+        <p:nvSpPr>
+          <p:cNvPr id="33" name="Text 23"/>
           <p:cNvSpPr txBox="1"/>
           <p:nvPr/>
         </p:nvSpPr>
         <p:spPr>
           <a:xfrm>
-            <a:off x="548640" y="6528816"/>
-            <a:ext cx="6400800" cy="256032"/>
+            <a:off x="1371600" y="5705856"/>
+            <a:ext cx="10058400" cy="256032"/>
           </a:xfrm>
           <a:prstGeom prst="rect">
             <a:avLst/>
@@ -15820,14 +16020,95 @@
               <a:buNone/>
             </a:pPr>
             <a:r>
-              <a:rPr lang="en-US" sz="900" dirty="0">
-                <a:solidFill>
-                  <a:srgbClr val="90A5A7"/>
+              <a:rPr lang="en-US" sz="1350" b="1" dirty="0">
+                <a:solidFill>
+                  <a:srgbClr val="013A40"/>
+                </a:solidFill>
+                <a:latin typeface="Cambria" pitchFamily="34" charset="0"/>
+                <a:ea typeface="Cambria" pitchFamily="34" charset="-122"/>
+                <a:cs typeface="Cambria" pitchFamily="34" charset="-120"/>
+              </a:rPr>
+              <a:t>Enfoque práctico</a:t>
+            </a:r>
+            <a:endParaRPr lang="en-US" sz="1350" dirty="0"/>
+          </a:p>
+        </p:txBody>
+      </p:sp>
+      <p:sp>
+        <p:nvSpPr>
+          <p:cNvPr id="34" name="Text 24"/>
+          <p:cNvSpPr txBox="1"/>
+          <p:nvPr/>
+        </p:nvSpPr>
+        <p:spPr>
+          <a:xfrm>
+            <a:off x="1371600" y="5980176"/>
+            <a:ext cx="10058400" cy="274320"/>
+          </a:xfrm>
+          <a:prstGeom prst="rect">
+            <a:avLst/>
+          </a:prstGeom>
+          <a:noFill/>
+          <a:ln/>
+        </p:spPr>
+        <p:txBody>
+          <a:bodyPr wrap="square" lIns="0" tIns="0" rIns="0" bIns="0" rtlCol="0" anchor="t"/>
+          <a:lstStyle/>
+          <a:p>
+            <a:pPr indent="0" marL="0">
+              <a:lnSpc>
+                <a:spcPct val="112000"/>
+              </a:lnSpc>
+              <a:buNone/>
+            </a:pPr>
+            <a:r>
+              <a:rPr lang="en-US" sz="1150" dirty="0">
+                <a:solidFill>
+                  <a:srgbClr val="013A40"/>
                 </a:solidFill>
                 <a:latin typeface="Calibri" pitchFamily="34" charset="0"/>
                 <a:ea typeface="Calibri" pitchFamily="34" charset="-122"/>
                 <a:cs typeface="Calibri" pitchFamily="34" charset="-120"/>
               </a:rPr>
+              <a:t>El examen físico preanestésico debe completarse siempre, incluso en cirugías menores: hallazgos incidentales (soplo no documentado, vía aérea límite) cambian con frecuencia el plan anestésico.</a:t>
+            </a:r>
+            <a:endParaRPr lang="en-US" sz="1150" dirty="0"/>
+          </a:p>
+        </p:txBody>
+      </p:sp>
+      <p:sp>
+        <p:nvSpPr>
+          <p:cNvPr id="35" name="Text 25"/>
+          <p:cNvSpPr txBox="1"/>
+          <p:nvPr/>
+        </p:nvSpPr>
+        <p:spPr>
+          <a:xfrm>
+            <a:off x="548640" y="6528816"/>
+            <a:ext cx="6400800" cy="256032"/>
+          </a:xfrm>
+          <a:prstGeom prst="rect">
+            <a:avLst/>
+          </a:prstGeom>
+          <a:noFill/>
+          <a:ln/>
+        </p:spPr>
+        <p:txBody>
+          <a:bodyPr wrap="square" lIns="0" tIns="0" rIns="0" bIns="0" rtlCol="0" anchor="ctr"/>
+          <a:lstStyle/>
+          <a:p>
+            <a:pPr indent="0" marL="0">
+              <a:buNone/>
+            </a:pPr>
+            <a:r>
+              <a:rPr lang="en-US" sz="900" dirty="0">
+                <a:solidFill>
+                  <a:srgbClr val="90A5A7"/>
+                </a:solidFill>
+                <a:latin typeface="Calibri" pitchFamily="34" charset="0"/>
+                <a:ea typeface="Calibri" pitchFamily="34" charset="-122"/>
+                <a:cs typeface="Calibri" pitchFamily="34" charset="-120"/>
+              </a:rPr>
               <a:t>Capítulo III  ·  Evaluación Preanestésica</a:t>
             </a:r>
             <a:endParaRPr lang="en-US" sz="900" dirty="0"/>
@@ -15836,7 +16117,7 @@
       </p:sp>
       <p:sp>
         <p:nvSpPr>
-          <p:cNvPr id="31" name="Text 22"/>
+          <p:cNvPr id="36" name="Text 26"/>
           <p:cNvSpPr txBox="1"/>
           <p:nvPr/>
         </p:nvSpPr>
@@ -18026,7 +18307,7 @@
         </p:nvSpPr>
         <p:spPr>
           <a:xfrm>
-            <a:off x="548640" y="3977640"/>
+            <a:off x="548640" y="4370832"/>
             <a:ext cx="6675120" cy="320040"/>
           </a:xfrm>
           <a:prstGeom prst="rect">
@@ -18060,6 +18341,153 @@
       <p:sp>
         <p:nvSpPr>
           <p:cNvPr id="9" name="Shape 5"/>
+          <p:cNvSpPr/>
+          <p:nvPr/>
+        </p:nvSpPr>
+        <p:spPr>
+          <a:xfrm>
+            <a:off x="548640" y="4800600"/>
+            <a:ext cx="6675120" cy="1188720"/>
+          </a:xfrm>
+          <a:prstGeom prst="roundRect">
+            <a:avLst>
+              <a:gd name="adj" fmla="val 6154"/>
+            </a:avLst>
+          </a:prstGeom>
+          <a:solidFill>
+            <a:srgbClr val="EFF7F7"/>
+          </a:solidFill>
+          <a:ln/>
+        </p:spPr>
+      </p:sp>
+      <p:sp>
+        <p:nvSpPr>
+          <p:cNvPr id="10" name="Shape 6"/>
+          <p:cNvSpPr/>
+          <p:nvPr/>
+        </p:nvSpPr>
+        <p:spPr>
+          <a:xfrm>
+            <a:off x="749808" y="5157216"/>
+            <a:ext cx="475488" cy="475488"/>
+          </a:xfrm>
+          <a:prstGeom prst="ellipse">
+            <a:avLst/>
+          </a:prstGeom>
+          <a:solidFill>
+            <a:srgbClr val="00A896"/>
+          </a:solidFill>
+          <a:ln/>
+        </p:spPr>
+      </p:sp>
+      <p:pic>
+        <p:nvPicPr>
+          <p:cNvPr id="11" name="Image 1" descr="/tmp/claude-0/-home-user-gpa-academy1/adc6e4aa-3b77-57c1-ba92-a8d4ee625c84/scratchpad/pptx_ch3/icons/checklist_white.png">    </p:cNvPr>
+          <p:cNvPicPr>
+            <a:picLocks noChangeAspect="1"/>
+          </p:cNvPicPr>
+          <p:nvPr/>
+        </p:nvPicPr>
+        <p:blipFill>
+          <a:blip r:embed="rId2"/>
+          <a:stretch>
+            <a:fillRect/>
+          </a:stretch>
+        </p:blipFill>
+        <p:spPr>
+          <a:xfrm>
+            <a:off x="854415" y="5261823"/>
+            <a:ext cx="266273" cy="266273"/>
+          </a:xfrm>
+          <a:prstGeom prst="rect">
+            <a:avLst/>
+          </a:prstGeom>
+        </p:spPr>
+      </p:pic>
+      <p:sp>
+        <p:nvSpPr>
+          <p:cNvPr id="12" name="Text 7"/>
+          <p:cNvSpPr txBox="1"/>
+          <p:nvPr/>
+        </p:nvSpPr>
+        <p:spPr>
+          <a:xfrm>
+            <a:off x="1371600" y="4928616"/>
+            <a:ext cx="5669280" cy="256032"/>
+          </a:xfrm>
+          <a:prstGeom prst="rect">
+            <a:avLst/>
+          </a:prstGeom>
+          <a:noFill/>
+          <a:ln/>
+        </p:spPr>
+        <p:txBody>
+          <a:bodyPr wrap="square" lIns="0" tIns="0" rIns="0" bIns="0" rtlCol="0" anchor="ctr"/>
+          <a:lstStyle/>
+          <a:p>
+            <a:pPr indent="0" marL="0">
+              <a:buNone/>
+            </a:pPr>
+            <a:r>
+              <a:rPr lang="en-US" sz="1350" b="1" dirty="0">
+                <a:solidFill>
+                  <a:srgbClr val="013A40"/>
+                </a:solidFill>
+                <a:latin typeface="Cambria" pitchFamily="34" charset="0"/>
+                <a:ea typeface="Cambria" pitchFamily="34" charset="-122"/>
+                <a:cs typeface="Cambria" pitchFamily="34" charset="-120"/>
+              </a:rPr>
+              <a:t>Técnica correcta de exploración</a:t>
+            </a:r>
+            <a:endParaRPr lang="en-US" sz="1350" dirty="0"/>
+          </a:p>
+        </p:txBody>
+      </p:sp>
+      <p:sp>
+        <p:nvSpPr>
+          <p:cNvPr id="13" name="Text 8"/>
+          <p:cNvSpPr txBox="1"/>
+          <p:nvPr/>
+        </p:nvSpPr>
+        <p:spPr>
+          <a:xfrm>
+            <a:off x="1371600" y="5202936"/>
+            <a:ext cx="5669280" cy="685800"/>
+          </a:xfrm>
+          <a:prstGeom prst="rect">
+            <a:avLst/>
+          </a:prstGeom>
+          <a:noFill/>
+          <a:ln/>
+        </p:spPr>
+        <p:txBody>
+          <a:bodyPr wrap="square" lIns="0" tIns="0" rIns="0" bIns="0" rtlCol="0" anchor="t"/>
+          <a:lstStyle/>
+          <a:p>
+            <a:pPr indent="0" marL="0">
+              <a:lnSpc>
+                <a:spcPct val="112000"/>
+              </a:lnSpc>
+              <a:buNone/>
+            </a:pPr>
+            <a:r>
+              <a:rPr lang="en-US" sz="1150" dirty="0">
+                <a:solidFill>
+                  <a:srgbClr val="013A40"/>
+                </a:solidFill>
+                <a:latin typeface="Calibri" pitchFamily="34" charset="0"/>
+                <a:ea typeface="Calibri" pitchFamily="34" charset="-122"/>
+                <a:cs typeface="Calibri" pitchFamily="34" charset="-120"/>
+              </a:rPr>
+              <a:t>Explorar con el paciente sentado, cabeza en posición neutra, boca abierta al máximo y lengua protruida sin fonar: fonar durante la maniobra eleva falsamente la clase visualizada y subestima el riesgo real.</a:t>
+            </a:r>
+            <a:endParaRPr lang="en-US" sz="1150" dirty="0"/>
+          </a:p>
+        </p:txBody>
+      </p:sp>
+      <p:sp>
+        <p:nvSpPr>
+          <p:cNvPr id="14" name="Shape 9"/>
           <p:cNvSpPr/>
           <p:nvPr/>
         </p:nvSpPr>
@@ -18093,7 +18521,7 @@
       </p:sp>
       <p:sp>
         <p:nvSpPr>
-          <p:cNvPr id="10" name="Text 6"/>
+          <p:cNvPr id="15" name="Text 10"/>
           <p:cNvSpPr txBox="1"/>
           <p:nvPr/>
         </p:nvSpPr>
@@ -18132,7 +18560,7 @@
       </p:sp>
       <p:sp>
         <p:nvSpPr>
-          <p:cNvPr id="11" name="Text 7"/>
+          <p:cNvPr id="16" name="Text 11"/>
           <p:cNvSpPr txBox="1"/>
           <p:nvPr/>
         </p:nvSpPr>
@@ -18256,7 +18684,7 @@
       </p:sp>
       <p:sp>
         <p:nvSpPr>
-          <p:cNvPr id="12" name="Text 8"/>
+          <p:cNvPr id="17" name="Text 12"/>
           <p:cNvSpPr txBox="1"/>
           <p:nvPr/>
         </p:nvSpPr>
@@ -18295,7 +18723,7 @@
       </p:sp>
       <p:sp>
         <p:nvSpPr>
-          <p:cNvPr id="13" name="Text 9"/>
+          <p:cNvPr id="18" name="Text 13"/>
           <p:cNvSpPr txBox="1"/>
           <p:nvPr/>
         </p:nvSpPr>
@@ -19126,6 +19554,153 @@
         </p:nvSpPr>
         <p:spPr>
           <a:xfrm>
+            <a:off x="548640" y="5166360"/>
+            <a:ext cx="5394960" cy="1051560"/>
+          </a:xfrm>
+          <a:prstGeom prst="roundRect">
+            <a:avLst>
+              <a:gd name="adj" fmla="val 6957"/>
+            </a:avLst>
+          </a:prstGeom>
+          <a:solidFill>
+            <a:srgbClr val="EFF7F7"/>
+          </a:solidFill>
+          <a:ln/>
+        </p:spPr>
+      </p:sp>
+      <p:sp>
+        <p:nvSpPr>
+          <p:cNvPr id="23" name="Shape 20"/>
+          <p:cNvSpPr/>
+          <p:nvPr/>
+        </p:nvSpPr>
+        <p:spPr>
+          <a:xfrm>
+            <a:off x="749808" y="5454396"/>
+            <a:ext cx="475488" cy="475488"/>
+          </a:xfrm>
+          <a:prstGeom prst="ellipse">
+            <a:avLst/>
+          </a:prstGeom>
+          <a:solidFill>
+            <a:srgbClr val="028090"/>
+          </a:solidFill>
+          <a:ln/>
+        </p:spPr>
+      </p:sp>
+      <p:pic>
+        <p:nvPicPr>
+          <p:cNvPr id="24" name="Image 1" descr="/tmp/claude-0/-home-user-gpa-academy1/adc6e4aa-3b77-57c1-ba92-a8d4ee625c84/scratchpad/pptx_ch3/icons/warning_white.png">    </p:cNvPr>
+          <p:cNvPicPr>
+            <a:picLocks noChangeAspect="1"/>
+          </p:cNvPicPr>
+          <p:nvPr/>
+        </p:nvPicPr>
+        <p:blipFill>
+          <a:blip r:embed="rId2"/>
+          <a:stretch>
+            <a:fillRect/>
+          </a:stretch>
+        </p:blipFill>
+        <p:spPr>
+          <a:xfrm>
+            <a:off x="854415" y="5559003"/>
+            <a:ext cx="266273" cy="266273"/>
+          </a:xfrm>
+          <a:prstGeom prst="rect">
+            <a:avLst/>
+          </a:prstGeom>
+        </p:spPr>
+      </p:pic>
+      <p:sp>
+        <p:nvSpPr>
+          <p:cNvPr id="25" name="Text 21"/>
+          <p:cNvSpPr txBox="1"/>
+          <p:nvPr/>
+        </p:nvSpPr>
+        <p:spPr>
+          <a:xfrm>
+            <a:off x="1371600" y="5294376"/>
+            <a:ext cx="4389120" cy="256032"/>
+          </a:xfrm>
+          <a:prstGeom prst="rect">
+            <a:avLst/>
+          </a:prstGeom>
+          <a:noFill/>
+          <a:ln/>
+        </p:spPr>
+        <p:txBody>
+          <a:bodyPr wrap="square" lIns="0" tIns="0" rIns="0" bIns="0" rtlCol="0" anchor="ctr"/>
+          <a:lstStyle/>
+          <a:p>
+            <a:pPr indent="0" marL="0">
+              <a:buNone/>
+            </a:pPr>
+            <a:r>
+              <a:rPr lang="en-US" sz="1350" b="1" dirty="0">
+                <a:solidFill>
+                  <a:srgbClr val="013A40"/>
+                </a:solidFill>
+                <a:latin typeface="Cambria" pitchFamily="34" charset="0"/>
+                <a:ea typeface="Cambria" pitchFamily="34" charset="-122"/>
+                <a:cs typeface="Cambria" pitchFamily="34" charset="-120"/>
+              </a:rPr>
+              <a:t>Cuando LEMON es positivo</a:t>
+            </a:r>
+            <a:endParaRPr lang="en-US" sz="1350" dirty="0"/>
+          </a:p>
+        </p:txBody>
+      </p:sp>
+      <p:sp>
+        <p:nvSpPr>
+          <p:cNvPr id="26" name="Text 22"/>
+          <p:cNvSpPr txBox="1"/>
+          <p:nvPr/>
+        </p:nvSpPr>
+        <p:spPr>
+          <a:xfrm>
+            <a:off x="1371600" y="5568696"/>
+            <a:ext cx="4389120" cy="548640"/>
+          </a:xfrm>
+          <a:prstGeom prst="rect">
+            <a:avLst/>
+          </a:prstGeom>
+          <a:noFill/>
+          <a:ln/>
+        </p:spPr>
+        <p:txBody>
+          <a:bodyPr wrap="square" lIns="0" tIns="0" rIns="0" bIns="0" rtlCol="0" anchor="t"/>
+          <a:lstStyle/>
+          <a:p>
+            <a:pPr indent="0" marL="0">
+              <a:lnSpc>
+                <a:spcPct val="112000"/>
+              </a:lnSpc>
+              <a:buNone/>
+            </a:pPr>
+            <a:r>
+              <a:rPr lang="en-US" sz="1150" dirty="0">
+                <a:solidFill>
+                  <a:srgbClr val="013A40"/>
+                </a:solidFill>
+                <a:latin typeface="Calibri" pitchFamily="34" charset="0"/>
+                <a:ea typeface="Calibri" pitchFamily="34" charset="-122"/>
+                <a:cs typeface="Calibri" pitchFamily="34" charset="-120"/>
+              </a:rPr>
+              <a:t>Ante hallazgos positivos, planificar con dispositivos y personal adicional (videolaringoscopio, set de vía aérea difícil, segundo operador) antes de iniciar la inducción.</a:t>
+            </a:r>
+            <a:endParaRPr lang="en-US" sz="1150" dirty="0"/>
+          </a:p>
+        </p:txBody>
+      </p:sp>
+      <p:sp>
+        <p:nvSpPr>
+          <p:cNvPr id="27" name="Shape 23"/>
+          <p:cNvSpPr/>
+          <p:nvPr/>
+        </p:nvSpPr>
+        <p:spPr>
+          <a:xfrm>
             <a:off x="6263640" y="1572768"/>
             <a:ext cx="5394960" cy="4434840"/>
           </a:xfrm>
@@ -19154,7 +19729,7 @@
       </p:sp>
       <p:sp>
         <p:nvSpPr>
-          <p:cNvPr id="23" name="Text 20"/>
+          <p:cNvPr id="28" name="Text 24"/>
           <p:cNvSpPr txBox="1"/>
           <p:nvPr/>
         </p:nvSpPr>
@@ -19193,7 +19768,7 @@
       </p:sp>
       <p:sp>
         <p:nvSpPr>
-          <p:cNvPr id="24" name="Text 21"/>
+          <p:cNvPr id="29" name="Text 25"/>
           <p:cNvSpPr txBox="1"/>
           <p:nvPr/>
         </p:nvSpPr>
@@ -19359,7 +19934,7 @@
       </p:sp>
       <p:sp>
         <p:nvSpPr>
-          <p:cNvPr id="25" name="Text 22"/>
+          <p:cNvPr id="30" name="Text 26"/>
           <p:cNvSpPr txBox="1"/>
           <p:nvPr/>
         </p:nvSpPr>
@@ -19398,7 +19973,7 @@
       </p:sp>
       <p:sp>
         <p:nvSpPr>
-          <p:cNvPr id="26" name="Text 23"/>
+          <p:cNvPr id="31" name="Text 27"/>
           <p:cNvSpPr txBox="1"/>
           <p:nvPr/>
         </p:nvSpPr>
@@ -19781,14 +20356,48 @@
       </p:sp>
       <p:sp>
         <p:nvSpPr>
-          <p:cNvPr id="8" name="Text 5"/>
+          <p:cNvPr id="8" name="Shape 5"/>
+          <p:cNvSpPr/>
+          <p:nvPr/>
+        </p:nvSpPr>
+        <p:spPr>
+          <a:xfrm>
+            <a:off x="548640" y="4709160"/>
+            <a:ext cx="5394960" cy="1417320"/>
+          </a:xfrm>
+          <a:prstGeom prst="roundRect">
+            <a:avLst>
+              <a:gd name="adj" fmla="val 5161"/>
+            </a:avLst>
+          </a:prstGeom>
+          <a:solidFill>
+            <a:srgbClr val="F5FBFA"/>
+          </a:solidFill>
+          <a:ln w="12700">
+            <a:solidFill>
+              <a:srgbClr val="D9E9E8"/>
+            </a:solidFill>
+            <a:prstDash val="solid"/>
+          </a:ln>
+          <a:effectLst>
+            <a:outerShdw sx="100000" sy="100000" kx="0" ky="0" algn="bl" rotWithShape="0" blurRad="76200" dist="25400" dir="5400000">
+              <a:srgbClr val="1B2E30">
+                <a:alpha val="10000"/>
+              </a:srgbClr>
+            </a:outerShdw>
+          </a:effectLst>
+        </p:spPr>
+      </p:sp>
+      <p:sp>
+        <p:nvSpPr>
+          <p:cNvPr id="9" name="Text 6"/>
           <p:cNvSpPr txBox="1"/>
           <p:nvPr/>
         </p:nvSpPr>
         <p:spPr>
           <a:xfrm>
-            <a:off x="6263640" y="1572768"/>
-            <a:ext cx="5486400" cy="274320"/>
+            <a:off x="685800" y="4800600"/>
+            <a:ext cx="5120640" cy="566928"/>
           </a:xfrm>
           <a:prstGeom prst="rect">
             <a:avLst/>
@@ -19797,21 +20406,141 @@
           <a:ln/>
         </p:spPr>
         <p:txBody>
+          <a:bodyPr wrap="square" lIns="0" tIns="0" rIns="0" bIns="0" rtlCol="0" anchor="b"/>
+          <a:lstStyle/>
+          <a:p>
+            <a:pPr algn="ctr" indent="0" marL="0">
+              <a:buNone/>
+            </a:pPr>
+            <a:r>
+              <a:rPr lang="en-US" sz="2400" b="1" dirty="0">
+                <a:solidFill>
+                  <a:srgbClr val="00A896"/>
+                </a:solidFill>
+                <a:latin typeface="Cambria" pitchFamily="34" charset="0"/>
+                <a:ea typeface="Cambria" pitchFamily="34" charset="-122"/>
+                <a:cs typeface="Cambria" pitchFamily="34" charset="-120"/>
+              </a:rPr>
+              <a:t>STOP-BANG</a:t>
+            </a:r>
+            <a:endParaRPr lang="en-US" sz="2400" dirty="0"/>
+          </a:p>
+        </p:txBody>
+      </p:sp>
+      <p:sp>
+        <p:nvSpPr>
+          <p:cNvPr id="10" name="Text 7"/>
+          <p:cNvSpPr txBox="1"/>
+          <p:nvPr/>
+        </p:nvSpPr>
+        <p:spPr>
+          <a:xfrm>
+            <a:off x="685800" y="5422392"/>
+            <a:ext cx="5120640" cy="256032"/>
+          </a:xfrm>
+          <a:prstGeom prst="rect">
+            <a:avLst/>
+          </a:prstGeom>
+          <a:noFill/>
+          <a:ln/>
+        </p:spPr>
+        <p:txBody>
           <a:bodyPr wrap="square" lIns="0" tIns="0" rIns="0" bIns="0" rtlCol="0" anchor="ctr"/>
           <a:lstStyle/>
           <a:p>
-            <a:pPr indent="0" marL="0">
+            <a:pPr algn="ctr" indent="0" marL="0">
               <a:buNone/>
             </a:pPr>
             <a:r>
-              <a:rPr lang="en-US" sz="1300" b="1" spc="50" kern="0" dirty="0">
-                <a:solidFill>
-                  <a:srgbClr val="028090"/>
+              <a:rPr lang="en-US" sz="1150" b="1" dirty="0">
+                <a:solidFill>
+                  <a:srgbClr val="013A40"/>
                 </a:solidFill>
                 <a:latin typeface="Calibri" pitchFamily="34" charset="0"/>
                 <a:ea typeface="Calibri" pitchFamily="34" charset="-122"/>
                 <a:cs typeface="Calibri" pitchFamily="34" charset="-120"/>
               </a:rPr>
+              <a:t>Tamizaje de apnea obstructiva del sueño</a:t>
+            </a:r>
+            <a:endParaRPr lang="en-US" sz="1150" dirty="0"/>
+          </a:p>
+        </p:txBody>
+      </p:sp>
+      <p:sp>
+        <p:nvSpPr>
+          <p:cNvPr id="11" name="Text 8"/>
+          <p:cNvSpPr txBox="1"/>
+          <p:nvPr/>
+        </p:nvSpPr>
+        <p:spPr>
+          <a:xfrm>
+            <a:off x="685800" y="5696712"/>
+            <a:ext cx="5120640" cy="301752"/>
+          </a:xfrm>
+          <a:prstGeom prst="rect">
+            <a:avLst/>
+          </a:prstGeom>
+          <a:noFill/>
+          <a:ln/>
+        </p:spPr>
+        <p:txBody>
+          <a:bodyPr wrap="square" lIns="0" tIns="0" rIns="0" bIns="0" rtlCol="0" anchor="t"/>
+          <a:lstStyle/>
+          <a:p>
+            <a:pPr algn="ctr" indent="0" marL="0">
+              <a:lnSpc>
+                <a:spcPct val="105000"/>
+              </a:lnSpc>
+              <a:buNone/>
+            </a:pPr>
+            <a:r>
+              <a:rPr lang="en-US" sz="950" dirty="0">
+                <a:solidFill>
+                  <a:srgbClr val="52696C"/>
+                </a:solidFill>
+                <a:latin typeface="Calibri" pitchFamily="34" charset="0"/>
+                <a:ea typeface="Calibri" pitchFamily="34" charset="-122"/>
+                <a:cs typeface="Calibri" pitchFamily="34" charset="-120"/>
+              </a:rPr>
+              <a:t>Aplicar en la consulta ante ronquido, somnolencia diurna u obesidad: eleva el riesgo de vía aérea difícil y depresión respiratoria por opioides</a:t>
+            </a:r>
+            <a:endParaRPr lang="en-US" sz="950" dirty="0"/>
+          </a:p>
+        </p:txBody>
+      </p:sp>
+      <p:sp>
+        <p:nvSpPr>
+          <p:cNvPr id="12" name="Text 9"/>
+          <p:cNvSpPr txBox="1"/>
+          <p:nvPr/>
+        </p:nvSpPr>
+        <p:spPr>
+          <a:xfrm>
+            <a:off x="6263640" y="1572768"/>
+            <a:ext cx="5486400" cy="274320"/>
+          </a:xfrm>
+          <a:prstGeom prst="rect">
+            <a:avLst/>
+          </a:prstGeom>
+          <a:noFill/>
+          <a:ln/>
+        </p:spPr>
+        <p:txBody>
+          <a:bodyPr wrap="square" lIns="0" tIns="0" rIns="0" bIns="0" rtlCol="0" anchor="ctr"/>
+          <a:lstStyle/>
+          <a:p>
+            <a:pPr indent="0" marL="0">
+              <a:buNone/>
+            </a:pPr>
+            <a:r>
+              <a:rPr lang="en-US" sz="1300" b="1" spc="50" kern="0" dirty="0">
+                <a:solidFill>
+                  <a:srgbClr val="028090"/>
+                </a:solidFill>
+                <a:latin typeface="Calibri" pitchFamily="34" charset="0"/>
+                <a:ea typeface="Calibri" pitchFamily="34" charset="-122"/>
+                <a:cs typeface="Calibri" pitchFamily="34" charset="-120"/>
+              </a:rPr>
               <a:t>HALLAZGOS DE ALTO VALOR EN EL EXAMEN FÍSICO</a:t>
             </a:r>
             <a:endParaRPr lang="en-US" sz="1300" dirty="0"/>
@@ -19820,7 +20549,7 @@
       </p:sp>
       <p:sp>
         <p:nvSpPr>
-          <p:cNvPr id="9" name="Shape 6"/>
+          <p:cNvPr id="13" name="Shape 10"/>
           <p:cNvSpPr/>
           <p:nvPr/>
         </p:nvSpPr>
@@ -19840,7 +20569,7 @@
       </p:sp>
       <p:pic>
         <p:nvPicPr>
-          <p:cNvPr id="10" name="Image 1" descr="/tmp/claude-0/-home-user-gpa-academy1/adc6e4aa-3b77-57c1-ba92-a8d4ee625c84/scratchpad/pptx_ch3/icons/examBody_white.png">    </p:cNvPr>
+          <p:cNvPr id="14" name="Image 1" descr="/tmp/claude-0/-home-user-gpa-academy1/adc6e4aa-3b77-57c1-ba92-a8d4ee625c84/scratchpad/pptx_ch3/icons/examBody_white.png">    </p:cNvPr>
           <p:cNvPicPr>
             <a:picLocks noChangeAspect="1"/>
           </p:cNvPicPr>
@@ -19864,7 +20593,7 @@
       </p:pic>
       <p:sp>
         <p:nvSpPr>
-          <p:cNvPr id="11" name="Text 7"/>
+          <p:cNvPr id="15" name="Text 11"/>
           <p:cNvSpPr txBox="1"/>
           <p:nvPr/>
         </p:nvSpPr>
@@ -19903,7 +20632,7 @@
       </p:sp>
       <p:sp>
         <p:nvSpPr>
-          <p:cNvPr id="12" name="Text 8"/>
+          <p:cNvPr id="16" name="Text 12"/>
           <p:cNvSpPr txBox="1"/>
           <p:nvPr/>
         </p:nvSpPr>
@@ -19945,7 +20674,7 @@
       </p:sp>
       <p:sp>
         <p:nvSpPr>
-          <p:cNvPr id="13" name="Shape 9"/>
+          <p:cNvPr id="17" name="Shape 13"/>
           <p:cNvSpPr/>
           <p:nvPr/>
         </p:nvSpPr>
@@ -19965,7 +20694,7 @@
       </p:sp>
       <p:pic>
         <p:nvPicPr>
-          <p:cNvPr id="14" name="Image 2" descr="/tmp/claude-0/-home-user-gpa-academy1/adc6e4aa-3b77-57c1-ba92-a8d4ee625c84/scratchpad/pptx_ch3/icons/stethoscope_white.png">    </p:cNvPr>
+          <p:cNvPr id="18" name="Image 2" descr="/tmp/claude-0/-home-user-gpa-academy1/adc6e4aa-3b77-57c1-ba92-a8d4ee625c84/scratchpad/pptx_ch3/icons/stethoscope_white.png">    </p:cNvPr>
           <p:cNvPicPr>
             <a:picLocks noChangeAspect="1"/>
           </p:cNvPicPr>
@@ -19989,7 +20718,7 @@
       </p:pic>
       <p:sp>
         <p:nvSpPr>
-          <p:cNvPr id="15" name="Text 10"/>
+          <p:cNvPr id="19" name="Text 14"/>
           <p:cNvSpPr txBox="1"/>
           <p:nvPr/>
         </p:nvSpPr>
@@ -20028,7 +20757,7 @@
       </p:sp>
       <p:sp>
         <p:nvSpPr>
-          <p:cNvPr id="16" name="Text 11"/>
+          <p:cNvPr id="20" name="Text 15"/>
           <p:cNvSpPr txBox="1"/>
           <p:nvPr/>
         </p:nvSpPr>
@@ -20070,7 +20799,7 @@
       </p:sp>
       <p:sp>
         <p:nvSpPr>
-          <p:cNvPr id="17" name="Shape 12"/>
+          <p:cNvPr id="21" name="Shape 16"/>
           <p:cNvSpPr/>
           <p:nvPr/>
         </p:nvSpPr>
@@ -20090,7 +20819,7 @@
       </p:sp>
       <p:pic>
         <p:nvPicPr>
-          <p:cNvPr id="18" name="Image 3" descr="/tmp/claude-0/-home-user-gpa-academy1/adc6e4aa-3b77-57c1-ba92-a8d4ee625c84/scratchpad/pptx_ch3/icons/scale_white.png">    </p:cNvPr>
+          <p:cNvPr id="22" name="Image 3" descr="/tmp/claude-0/-home-user-gpa-academy1/adc6e4aa-3b77-57c1-ba92-a8d4ee625c84/scratchpad/pptx_ch3/icons/scale_white.png">    </p:cNvPr>
           <p:cNvPicPr>
             <a:picLocks noChangeAspect="1"/>
           </p:cNvPicPr>
@@ -20114,7 +20843,7 @@
       </p:pic>
       <p:sp>
         <p:nvSpPr>
-          <p:cNvPr id="19" name="Text 13"/>
+          <p:cNvPr id="23" name="Text 17"/>
           <p:cNvSpPr txBox="1"/>
           <p:nvPr/>
         </p:nvSpPr>
@@ -20153,7 +20882,7 @@
       </p:sp>
       <p:sp>
         <p:nvSpPr>
-          <p:cNvPr id="20" name="Text 14"/>
+          <p:cNvPr id="24" name="Text 18"/>
           <p:cNvSpPr txBox="1"/>
           <p:nvPr/>
         </p:nvSpPr>
@@ -20195,7 +20924,7 @@
       </p:sp>
       <p:sp>
         <p:nvSpPr>
-          <p:cNvPr id="21" name="Shape 15"/>
+          <p:cNvPr id="25" name="Shape 19"/>
           <p:cNvSpPr/>
           <p:nvPr/>
         </p:nvSpPr>
@@ -20217,7 +20946,7 @@
       </p:sp>
       <p:sp>
         <p:nvSpPr>
-          <p:cNvPr id="22" name="Shape 16"/>
+          <p:cNvPr id="26" name="Shape 20"/>
           <p:cNvSpPr/>
           <p:nvPr/>
         </p:nvSpPr>
@@ -20237,7 +20966,7 @@
       </p:sp>
       <p:pic>
         <p:nvPicPr>
-          <p:cNvPr id="23" name="Image 4" descr="/tmp/claude-0/-home-user-gpa-academy1/adc6e4aa-3b77-57c1-ba92-a8d4ee625c84/scratchpad/pptx_ch3/icons/warning_white.png">    </p:cNvPr>
+          <p:cNvPr id="27" name="Image 4" descr="/tmp/claude-0/-home-user-gpa-academy1/adc6e4aa-3b77-57c1-ba92-a8d4ee625c84/scratchpad/pptx_ch3/icons/warning_white.png">    </p:cNvPr>
           <p:cNvPicPr>
             <a:picLocks noChangeAspect="1"/>
           </p:cNvPicPr>
@@ -20261,7 +20990,7 @@
       </p:pic>
       <p:sp>
         <p:nvSpPr>
-          <p:cNvPr id="24" name="Text 17"/>
+          <p:cNvPr id="28" name="Text 21"/>
           <p:cNvSpPr txBox="1"/>
           <p:nvPr/>
         </p:nvSpPr>
@@ -20300,7 +21029,7 @@
       </p:sp>
       <p:sp>
         <p:nvSpPr>
-          <p:cNvPr id="25" name="Text 18"/>
+          <p:cNvPr id="29" name="Text 22"/>
           <p:cNvSpPr txBox="1"/>
           <p:nvPr/>
         </p:nvSpPr>
@@ -20342,7 +21071,7 @@
       </p:sp>
       <p:sp>
         <p:nvSpPr>
-          <p:cNvPr id="26" name="Text 19"/>
+          <p:cNvPr id="30" name="Text 23"/>
           <p:cNvSpPr txBox="1"/>
           <p:nvPr/>
         </p:nvSpPr>
@@ -20381,7 +21110,7 @@
       </p:sp>
       <p:sp>
         <p:nvSpPr>
-          <p:cNvPr id="27" name="Text 20"/>
+          <p:cNvPr id="31" name="Text 24"/>
           <p:cNvSpPr txBox="1"/>
           <p:nvPr/>
         </p:nvSpPr>
@@ -21478,42 +22207,25 @@
       </p:sp>
       <p:sp>
         <p:nvSpPr>
-          <p:cNvPr id="8" name="Text 5"/>
-          <p:cNvSpPr txBox="1"/>
-          <p:nvPr/>
-        </p:nvSpPr>
-        <p:spPr>
-          <a:xfrm>
-            <a:off x="6263640" y="1572768"/>
-            <a:ext cx="5486400" cy="274320"/>
-          </a:xfrm>
-          <a:prstGeom prst="rect">
-            <a:avLst/>
-          </a:prstGeom>
-          <a:noFill/>
-          <a:ln/>
-        </p:spPr>
-        <p:txBody>
-          <a:bodyPr wrap="square" lIns="0" tIns="0" rIns="0" bIns="0" rtlCol="0" anchor="ctr"/>
-          <a:lstStyle/>
-          <a:p>
-            <a:pPr indent="0" marL="0">
-              <a:buNone/>
-            </a:pPr>
-            <a:r>
-              <a:rPr lang="en-US" sz="1300" b="1" spc="50" kern="0" dirty="0">
-                <a:solidFill>
-                  <a:srgbClr val="028090"/>
-                </a:solidFill>
-                <a:latin typeface="Calibri" pitchFamily="34" charset="0"/>
-                <a:ea typeface="Calibri" pitchFamily="34" charset="-122"/>
-                <a:cs typeface="Calibri" pitchFamily="34" charset="-120"/>
-              </a:rPr>
-              <a:t>HALLAZGOS CLAVE DEL EXAMEN CARDIACO</a:t>
-            </a:r>
-            <a:endParaRPr lang="en-US" sz="1300" dirty="0"/>
-          </a:p>
-        </p:txBody>
+          <p:cNvPr id="8" name="Shape 5"/>
+          <p:cNvSpPr/>
+          <p:nvPr/>
+        </p:nvSpPr>
+        <p:spPr>
+          <a:xfrm>
+            <a:off x="548640" y="4709160"/>
+            <a:ext cx="5394960" cy="1417320"/>
+          </a:xfrm>
+          <a:prstGeom prst="roundRect">
+            <a:avLst>
+              <a:gd name="adj" fmla="val 5161"/>
+            </a:avLst>
+          </a:prstGeom>
+          <a:solidFill>
+            <a:srgbClr val="EFF7F7"/>
+          </a:solidFill>
+          <a:ln/>
+        </p:spPr>
       </p:sp>
       <p:sp>
         <p:nvSpPr>
@@ -21523,7 +22235,7 @@
         </p:nvSpPr>
         <p:spPr>
           <a:xfrm>
-            <a:off x="6263640" y="1901952"/>
+            <a:off x="749808" y="5180076"/>
             <a:ext cx="475488" cy="475488"/>
           </a:xfrm>
           <a:prstGeom prst="ellipse">
@@ -21537,7 +22249,7 @@
       </p:sp>
       <p:pic>
         <p:nvPicPr>
-          <p:cNvPr id="10" name="Image 1" descr="/tmp/claude-0/-home-user-gpa-academy1/adc6e4aa-3b77-57c1-ba92-a8d4ee625c84/scratchpad/pptx_ch3/icons/heart_white.png">    </p:cNvPr>
+          <p:cNvPr id="10" name="Image 1" descr="/tmp/claude-0/-home-user-gpa-academy1/adc6e4aa-3b77-57c1-ba92-a8d4ee625c84/scratchpad/pptx_ch3/icons/checklist_white.png">    </p:cNvPr>
           <p:cNvPicPr>
             <a:picLocks noChangeAspect="1"/>
           </p:cNvPicPr>
@@ -21551,8 +22263,8 @@
         </p:blipFill>
         <p:spPr>
           <a:xfrm>
-            <a:off x="6370625" y="2008937"/>
-            <a:ext cx="261518" cy="261518"/>
+            <a:off x="854415" y="5284683"/>
+            <a:ext cx="266273" cy="266273"/>
           </a:xfrm>
           <a:prstGeom prst="rect">
             <a:avLst/>
@@ -21567,8 +22279,8 @@
         </p:nvSpPr>
         <p:spPr>
           <a:xfrm>
-            <a:off x="6940296" y="1865376"/>
-            <a:ext cx="4718304" cy="256032"/>
+            <a:off x="1371600" y="4837176"/>
+            <a:ext cx="4389120" cy="256032"/>
           </a:xfrm>
           <a:prstGeom prst="rect">
             <a:avLst/>
@@ -21584,7 +22296,7 @@
               <a:buNone/>
             </a:pPr>
             <a:r>
-              <a:rPr lang="en-US" sz="1250" b="1" dirty="0">
+              <a:rPr lang="en-US" sz="1350" b="1" dirty="0">
                 <a:solidFill>
                   <a:srgbClr val="013A40"/>
                 </a:solidFill>
@@ -21592,9 +22304,9 @@
                 <a:ea typeface="Cambria" pitchFamily="34" charset="-122"/>
                 <a:cs typeface="Cambria" pitchFamily="34" charset="-120"/>
               </a:rPr>
-              <a:t>Auscultación cardiaca</a:t>
-            </a:r>
-            <a:endParaRPr lang="en-US" sz="1250" dirty="0"/>
+              <a:t>Equivalentes metabólicos de referencia</a:t>
+            </a:r>
+            <a:endParaRPr lang="en-US" sz="1350" dirty="0"/>
           </a:p>
         </p:txBody>
       </p:sp>
@@ -21606,8 +22318,8 @@
         </p:nvSpPr>
         <p:spPr>
           <a:xfrm>
-            <a:off x="6940296" y="2130552"/>
-            <a:ext cx="4718304" cy="822960"/>
+            <a:off x="1371600" y="5111496"/>
+            <a:ext cx="4389120" cy="914400"/>
           </a:xfrm>
           <a:prstGeom prst="rect">
             <a:avLst/>
@@ -21621,48 +22333,87 @@
           <a:p>
             <a:pPr indent="0" marL="0">
               <a:lnSpc>
-                <a:spcPct val="110000"/>
+                <a:spcPct val="112000"/>
               </a:lnSpc>
               <a:buNone/>
             </a:pPr>
             <a:r>
-              <a:rPr lang="en-US" sz="1100" dirty="0">
-                <a:solidFill>
-                  <a:srgbClr val="52696C"/>
+              <a:rPr lang="en-US" sz="1150" dirty="0">
+                <a:solidFill>
+                  <a:srgbClr val="013A40"/>
                 </a:solidFill>
                 <a:latin typeface="Calibri" pitchFamily="34" charset="0"/>
                 <a:ea typeface="Calibri" pitchFamily="34" charset="-122"/>
                 <a:cs typeface="Calibri" pitchFamily="34" charset="-120"/>
               </a:rPr>
-              <a:t>Soplos, ritmo irregular, tercer o cuarto ruido; sugieren valvulopatía o disfunción ventricular.</a:t>
-            </a:r>
-            <a:endParaRPr lang="en-US" sz="1100" dirty="0"/>
-          </a:p>
-        </p:txBody>
-      </p:sp>
-      <p:sp>
-        <p:nvSpPr>
-          <p:cNvPr id="13" name="Shape 9"/>
+              <a:t>1 MET: actividades básicas de autocuidado.  4 METs: subir un piso de escaleras o caminar rápido en plano.  ≥10 METs: deportes extenuantes. Preguntar siempre en términos concretos de esfuerzo diario.</a:t>
+            </a:r>
+            <a:endParaRPr lang="en-US" sz="1150" dirty="0"/>
+          </a:p>
+        </p:txBody>
+      </p:sp>
+      <p:sp>
+        <p:nvSpPr>
+          <p:cNvPr id="13" name="Text 9"/>
+          <p:cNvSpPr txBox="1"/>
+          <p:nvPr/>
+        </p:nvSpPr>
+        <p:spPr>
+          <a:xfrm>
+            <a:off x="6263640" y="1572768"/>
+            <a:ext cx="5486400" cy="274320"/>
+          </a:xfrm>
+          <a:prstGeom prst="rect">
+            <a:avLst/>
+          </a:prstGeom>
+          <a:noFill/>
+          <a:ln/>
+        </p:spPr>
+        <p:txBody>
+          <a:bodyPr wrap="square" lIns="0" tIns="0" rIns="0" bIns="0" rtlCol="0" anchor="ctr"/>
+          <a:lstStyle/>
+          <a:p>
+            <a:pPr indent="0" marL="0">
+              <a:buNone/>
+            </a:pPr>
+            <a:r>
+              <a:rPr lang="en-US" sz="1300" b="1" spc="50" kern="0" dirty="0">
+                <a:solidFill>
+                  <a:srgbClr val="028090"/>
+                </a:solidFill>
+                <a:latin typeface="Calibri" pitchFamily="34" charset="0"/>
+                <a:ea typeface="Calibri" pitchFamily="34" charset="-122"/>
+                <a:cs typeface="Calibri" pitchFamily="34" charset="-120"/>
+              </a:rPr>
+              <a:t>HALLAZGOS CLAVE DEL EXAMEN CARDIACO</a:t>
+            </a:r>
+            <a:endParaRPr lang="en-US" sz="1300" dirty="0"/>
+          </a:p>
+        </p:txBody>
+      </p:sp>
+      <p:sp>
+        <p:nvSpPr>
+          <p:cNvPr id="14" name="Shape 10"/>
           <p:cNvSpPr/>
           <p:nvPr/>
         </p:nvSpPr>
         <p:spPr>
           <a:xfrm>
-            <a:off x="6263640" y="2862072"/>
+            <a:off x="6263640" y="1901952"/>
             <a:ext cx="475488" cy="475488"/>
           </a:xfrm>
           <a:prstGeom prst="ellipse">
             <a:avLst/>
           </a:prstGeom>
           <a:solidFill>
-            <a:srgbClr val="00A896"/>
+            <a:srgbClr val="028090"/>
           </a:solidFill>
           <a:ln/>
         </p:spPr>
       </p:sp>
       <p:pic>
         <p:nvPicPr>
-          <p:cNvPr id="14" name="Image 2" descr="/tmp/claude-0/-home-user-gpa-academy1/adc6e4aa-3b77-57c1-ba92-a8d4ee625c84/scratchpad/pptx_ch3/icons/bp_white.png">    </p:cNvPr>
+          <p:cNvPr id="15" name="Image 2" descr="/tmp/claude-0/-home-user-gpa-academy1/adc6e4aa-3b77-57c1-ba92-a8d4ee625c84/scratchpad/pptx_ch3/icons/heart_white.png">    </p:cNvPr>
           <p:cNvPicPr>
             <a:picLocks noChangeAspect="1"/>
           </p:cNvPicPr>
@@ -21676,7 +22427,7 @@
         </p:blipFill>
         <p:spPr>
           <a:xfrm>
-            <a:off x="6370625" y="2969057"/>
+            <a:off x="6370625" y="2008937"/>
             <a:ext cx="261518" cy="261518"/>
           </a:xfrm>
           <a:prstGeom prst="rect">
@@ -21686,13 +22437,13 @@
       </p:pic>
       <p:sp>
         <p:nvSpPr>
-          <p:cNvPr id="15" name="Text 10"/>
+          <p:cNvPr id="16" name="Text 11"/>
           <p:cNvSpPr txBox="1"/>
           <p:nvPr/>
         </p:nvSpPr>
         <p:spPr>
           <a:xfrm>
-            <a:off x="6940296" y="2825496"/>
+            <a:off x="6940296" y="1865376"/>
             <a:ext cx="4718304" cy="256032"/>
           </a:xfrm>
           <a:prstGeom prst="rect">
@@ -21717,7 +22468,7 @@
                 <a:ea typeface="Cambria" pitchFamily="34" charset="-122"/>
                 <a:cs typeface="Cambria" pitchFamily="34" charset="-120"/>
               </a:rPr>
-              <a:t>Presión arterial y pulsos</a:t>
+              <a:t>Auscultación cardiaca</a:t>
             </a:r>
             <a:endParaRPr lang="en-US" sz="1250" dirty="0"/>
           </a:p>
@@ -21725,13 +22476,13 @@
       </p:sp>
       <p:sp>
         <p:nvSpPr>
-          <p:cNvPr id="16" name="Text 11"/>
+          <p:cNvPr id="17" name="Text 12"/>
           <p:cNvSpPr txBox="1"/>
           <p:nvPr/>
         </p:nvSpPr>
         <p:spPr>
           <a:xfrm>
-            <a:off x="6940296" y="3090672"/>
+            <a:off x="6940296" y="2130552"/>
             <a:ext cx="4718304" cy="822960"/>
           </a:xfrm>
           <a:prstGeom prst="rect">
@@ -21759,7 +22510,7 @@
                 <a:ea typeface="Calibri" pitchFamily="34" charset="-122"/>
                 <a:cs typeface="Calibri" pitchFamily="34" charset="-120"/>
               </a:rPr>
-              <a:t>Presión arterial en ambos brazos, simetría y amplitud de pulsos periféricos.</a:t>
+              <a:t>Soplos, ritmo irregular, tercer o cuarto ruido; sugieren valvulopatía o disfunción ventricular.</a:t>
             </a:r>
             <a:endParaRPr lang="en-US" sz="1100" dirty="0"/>
           </a:p>
@@ -21767,27 +22518,27 @@
       </p:sp>
       <p:sp>
         <p:nvSpPr>
-          <p:cNvPr id="17" name="Shape 12"/>
+          <p:cNvPr id="18" name="Shape 13"/>
           <p:cNvSpPr/>
           <p:nvPr/>
         </p:nvSpPr>
         <p:spPr>
           <a:xfrm>
-            <a:off x="6263640" y="3822192"/>
+            <a:off x="6263640" y="2862072"/>
             <a:ext cx="475488" cy="475488"/>
           </a:xfrm>
           <a:prstGeom prst="ellipse">
             <a:avLst/>
           </a:prstGeom>
           <a:solidFill>
-            <a:srgbClr val="02C39A"/>
+            <a:srgbClr val="00A896"/>
           </a:solidFill>
           <a:ln/>
         </p:spPr>
       </p:sp>
       <p:pic>
         <p:nvPicPr>
-          <p:cNvPr id="18" name="Image 3" descr="/tmp/claude-0/-home-user-gpa-academy1/adc6e4aa-3b77-57c1-ba92-a8d4ee625c84/scratchpad/pptx_ch3/icons/examBody_white.png">    </p:cNvPr>
+          <p:cNvPr id="19" name="Image 3" descr="/tmp/claude-0/-home-user-gpa-academy1/adc6e4aa-3b77-57c1-ba92-a8d4ee625c84/scratchpad/pptx_ch3/icons/bp_white.png">    </p:cNvPr>
           <p:cNvPicPr>
             <a:picLocks noChangeAspect="1"/>
           </p:cNvPicPr>
@@ -21801,7 +22552,7 @@
         </p:blipFill>
         <p:spPr>
           <a:xfrm>
-            <a:off x="6370625" y="3929177"/>
+            <a:off x="6370625" y="2969057"/>
             <a:ext cx="261518" cy="261518"/>
           </a:xfrm>
           <a:prstGeom prst="rect">
@@ -21811,13 +22562,13 @@
       </p:pic>
       <p:sp>
         <p:nvSpPr>
-          <p:cNvPr id="19" name="Text 13"/>
+          <p:cNvPr id="20" name="Text 14"/>
           <p:cNvSpPr txBox="1"/>
           <p:nvPr/>
         </p:nvSpPr>
         <p:spPr>
           <a:xfrm>
-            <a:off x="6940296" y="3785616"/>
+            <a:off x="6940296" y="2825496"/>
             <a:ext cx="4718304" cy="256032"/>
           </a:xfrm>
           <a:prstGeom prst="rect">
@@ -21842,7 +22593,7 @@
                 <a:ea typeface="Cambria" pitchFamily="34" charset="-122"/>
                 <a:cs typeface="Cambria" pitchFamily="34" charset="-120"/>
               </a:rPr>
-              <a:t>Signos de insuficiencia cardiaca</a:t>
+              <a:t>Presión arterial y pulsos</a:t>
             </a:r>
             <a:endParaRPr lang="en-US" sz="1250" dirty="0"/>
           </a:p>
@@ -21850,13 +22601,13 @@
       </p:sp>
       <p:sp>
         <p:nvSpPr>
-          <p:cNvPr id="20" name="Text 14"/>
+          <p:cNvPr id="21" name="Text 15"/>
           <p:cNvSpPr txBox="1"/>
           <p:nvPr/>
         </p:nvSpPr>
         <p:spPr>
           <a:xfrm>
-            <a:off x="6940296" y="4050792"/>
+            <a:off x="6940296" y="3090672"/>
             <a:ext cx="4718304" cy="822960"/>
           </a:xfrm>
           <a:prstGeom prst="rect">
@@ -21884,6 +22635,131 @@
                 <a:ea typeface="Calibri" pitchFamily="34" charset="-122"/>
                 <a:cs typeface="Calibri" pitchFamily="34" charset="-120"/>
               </a:rPr>
+              <a:t>Presión arterial en ambos brazos, simetría y amplitud de pulsos periféricos.</a:t>
+            </a:r>
+            <a:endParaRPr lang="en-US" sz="1100" dirty="0"/>
+          </a:p>
+        </p:txBody>
+      </p:sp>
+      <p:sp>
+        <p:nvSpPr>
+          <p:cNvPr id="22" name="Shape 16"/>
+          <p:cNvSpPr/>
+          <p:nvPr/>
+        </p:nvSpPr>
+        <p:spPr>
+          <a:xfrm>
+            <a:off x="6263640" y="3822192"/>
+            <a:ext cx="475488" cy="475488"/>
+          </a:xfrm>
+          <a:prstGeom prst="ellipse">
+            <a:avLst/>
+          </a:prstGeom>
+          <a:solidFill>
+            <a:srgbClr val="02C39A"/>
+          </a:solidFill>
+          <a:ln/>
+        </p:spPr>
+      </p:sp>
+      <p:pic>
+        <p:nvPicPr>
+          <p:cNvPr id="23" name="Image 4" descr="/tmp/claude-0/-home-user-gpa-academy1/adc6e4aa-3b77-57c1-ba92-a8d4ee625c84/scratchpad/pptx_ch3/icons/examBody_white.png">    </p:cNvPr>
+          <p:cNvPicPr>
+            <a:picLocks noChangeAspect="1"/>
+          </p:cNvPicPr>
+          <p:nvPr/>
+        </p:nvPicPr>
+        <p:blipFill>
+          <a:blip r:embed="rId5"/>
+          <a:stretch>
+            <a:fillRect/>
+          </a:stretch>
+        </p:blipFill>
+        <p:spPr>
+          <a:xfrm>
+            <a:off x="6370625" y="3929177"/>
+            <a:ext cx="261518" cy="261518"/>
+          </a:xfrm>
+          <a:prstGeom prst="rect">
+            <a:avLst/>
+          </a:prstGeom>
+        </p:spPr>
+      </p:pic>
+      <p:sp>
+        <p:nvSpPr>
+          <p:cNvPr id="24" name="Text 17"/>
+          <p:cNvSpPr txBox="1"/>
+          <p:nvPr/>
+        </p:nvSpPr>
+        <p:spPr>
+          <a:xfrm>
+            <a:off x="6940296" y="3785616"/>
+            <a:ext cx="4718304" cy="256032"/>
+          </a:xfrm>
+          <a:prstGeom prst="rect">
+            <a:avLst/>
+          </a:prstGeom>
+          <a:noFill/>
+          <a:ln/>
+        </p:spPr>
+        <p:txBody>
+          <a:bodyPr wrap="square" lIns="0" tIns="0" rIns="0" bIns="0" rtlCol="0" anchor="ctr"/>
+          <a:lstStyle/>
+          <a:p>
+            <a:pPr indent="0" marL="0">
+              <a:buNone/>
+            </a:pPr>
+            <a:r>
+              <a:rPr lang="en-US" sz="1250" b="1" dirty="0">
+                <a:solidFill>
+                  <a:srgbClr val="013A40"/>
+                </a:solidFill>
+                <a:latin typeface="Cambria" pitchFamily="34" charset="0"/>
+                <a:ea typeface="Cambria" pitchFamily="34" charset="-122"/>
+                <a:cs typeface="Cambria" pitchFamily="34" charset="-120"/>
+              </a:rPr>
+              <a:t>Signos de insuficiencia cardiaca</a:t>
+            </a:r>
+            <a:endParaRPr lang="en-US" sz="1250" dirty="0"/>
+          </a:p>
+        </p:txBody>
+      </p:sp>
+      <p:sp>
+        <p:nvSpPr>
+          <p:cNvPr id="25" name="Text 18"/>
+          <p:cNvSpPr txBox="1"/>
+          <p:nvPr/>
+        </p:nvSpPr>
+        <p:spPr>
+          <a:xfrm>
+            <a:off x="6940296" y="4050792"/>
+            <a:ext cx="4718304" cy="822960"/>
+          </a:xfrm>
+          <a:prstGeom prst="rect">
+            <a:avLst/>
+          </a:prstGeom>
+          <a:noFill/>
+          <a:ln/>
+        </p:spPr>
+        <p:txBody>
+          <a:bodyPr wrap="square" lIns="0" tIns="0" rIns="0" bIns="0" rtlCol="0" anchor="t"/>
+          <a:lstStyle/>
+          <a:p>
+            <a:pPr indent="0" marL="0">
+              <a:lnSpc>
+                <a:spcPct val="110000"/>
+              </a:lnSpc>
+              <a:buNone/>
+            </a:pPr>
+            <a:r>
+              <a:rPr lang="en-US" sz="1100" dirty="0">
+                <a:solidFill>
+                  <a:srgbClr val="52696C"/>
+                </a:solidFill>
+                <a:latin typeface="Calibri" pitchFamily="34" charset="0"/>
+                <a:ea typeface="Calibri" pitchFamily="34" charset="-122"/>
+                <a:cs typeface="Calibri" pitchFamily="34" charset="-120"/>
+              </a:rPr>
               <a:t>Ingurgitación yugular, edema, hepatomegalia, crépitos basales.</a:t>
             </a:r>
             <a:endParaRPr lang="en-US" sz="1100" dirty="0"/>
@@ -21892,18 +22768,18 @@
       </p:sp>
       <p:sp>
         <p:nvSpPr>
-          <p:cNvPr id="21" name="Shape 15"/>
+          <p:cNvPr id="26" name="Shape 19"/>
           <p:cNvSpPr/>
           <p:nvPr/>
         </p:nvSpPr>
         <p:spPr>
           <a:xfrm>
-            <a:off x="6263640" y="4892040"/>
-            <a:ext cx="5394960" cy="1097280"/>
+            <a:off x="6263640" y="4709160"/>
+            <a:ext cx="5394960" cy="1417320"/>
           </a:xfrm>
           <a:prstGeom prst="roundRect">
             <a:avLst>
-              <a:gd name="adj" fmla="val 6667"/>
+              <a:gd name="adj" fmla="val 5161"/>
             </a:avLst>
           </a:prstGeom>
           <a:solidFill>
@@ -21926,14 +22802,14 @@
       </p:sp>
       <p:sp>
         <p:nvSpPr>
-          <p:cNvPr id="22" name="Text 16"/>
+          <p:cNvPr id="27" name="Text 20"/>
           <p:cNvSpPr txBox="1"/>
           <p:nvPr/>
         </p:nvSpPr>
         <p:spPr>
           <a:xfrm>
-            <a:off x="6400800" y="4983480"/>
-            <a:ext cx="5120640" cy="548640"/>
+            <a:off x="6400800" y="4800600"/>
+            <a:ext cx="5120640" cy="566928"/>
           </a:xfrm>
           <a:prstGeom prst="rect">
             <a:avLst/>
@@ -21965,14 +22841,14 @@
       </p:sp>
       <p:sp>
         <p:nvSpPr>
-          <p:cNvPr id="23" name="Text 17"/>
+          <p:cNvPr id="28" name="Text 21"/>
           <p:cNvSpPr txBox="1"/>
           <p:nvPr/>
         </p:nvSpPr>
         <p:spPr>
           <a:xfrm>
-            <a:off x="6400800" y="5528462"/>
-            <a:ext cx="5120640" cy="274320"/>
+            <a:off x="6400800" y="5422392"/>
+            <a:ext cx="5120640" cy="256032"/>
           </a:xfrm>
           <a:prstGeom prst="rect">
             <a:avLst/>
@@ -22004,14 +22880,14 @@
       </p:sp>
       <p:sp>
         <p:nvSpPr>
-          <p:cNvPr id="24" name="Text 18"/>
+          <p:cNvPr id="29" name="Text 22"/>
           <p:cNvSpPr txBox="1"/>
           <p:nvPr/>
         </p:nvSpPr>
         <p:spPr>
           <a:xfrm>
-            <a:off x="6400800" y="5784494"/>
-            <a:ext cx="5120640" cy="329184"/>
+            <a:off x="6400800" y="5696712"/>
+            <a:ext cx="5120640" cy="301752"/>
           </a:xfrm>
           <a:prstGeom prst="rect">
             <a:avLst/>
@@ -22046,7 +22922,7 @@
       </p:sp>
       <p:sp>
         <p:nvSpPr>
-          <p:cNvPr id="25" name="Text 19"/>
+          <p:cNvPr id="30" name="Text 23"/>
           <p:cNvSpPr txBox="1"/>
           <p:nvPr/>
         </p:nvSpPr>
@@ -22085,7 +22961,7 @@
       </p:sp>
       <p:sp>
         <p:nvSpPr>
-          <p:cNvPr id="26" name="Text 20"/>
+          <p:cNvPr id="31" name="Text 24"/>
           <p:cNvSpPr txBox="1"/>
           <p:nvPr/>
         </p:nvSpPr>
@@ -22288,7 +23164,7 @@
         <p:spPr>
           <a:xfrm>
             <a:off x="548640" y="1627632"/>
-            <a:ext cx="7315200" cy="274320"/>
+            <a:ext cx="6035040" cy="274320"/>
           </a:xfrm>
           <a:prstGeom prst="rect">
             <a:avLst/>
@@ -22304,7 +23180,7 @@
               <a:buNone/>
             </a:pPr>
             <a:r>
-              <a:rPr lang="en-US" sz="1300" b="1" spc="50" kern="0" dirty="0">
+              <a:rPr lang="en-US" sz="1250" b="1" spc="50" kern="0" dirty="0">
                 <a:solidFill>
                   <a:srgbClr val="028090"/>
                 </a:solidFill>
@@ -22312,9 +23188,9 @@
                 <a:ea typeface="Calibri" pitchFamily="34" charset="-122"/>
                 <a:cs typeface="Calibri" pitchFamily="34" charset="-120"/>
               </a:rPr>
-              <a:t>ÍNDICE DE RIESGO CARDIACO REVISADO (LEE, RCRI) — 6 CRITERIOS</a:t>
-            </a:r>
-            <a:endParaRPr lang="en-US" sz="1300" dirty="0"/>
+              <a:t>ÍNDICE DE RIESGO CARDIACO REVISADO (LEE, RCRI): 6 CRITERIOS</a:t>
+            </a:r>
+            <a:endParaRPr lang="en-US" sz="1250" dirty="0"/>
           </a:p>
         </p:txBody>
       </p:sp>
@@ -22927,6 +23803,153 @@
       <p:sp>
         <p:nvSpPr>
           <p:cNvPr id="25" name="Shape 22"/>
+          <p:cNvSpPr/>
+          <p:nvPr/>
+        </p:nvSpPr>
+        <p:spPr>
+          <a:xfrm>
+            <a:off x="548640" y="5074920"/>
+            <a:ext cx="6035040" cy="960120"/>
+          </a:xfrm>
+          <a:prstGeom prst="roundRect">
+            <a:avLst>
+              <a:gd name="adj" fmla="val 7619"/>
+            </a:avLst>
+          </a:prstGeom>
+          <a:solidFill>
+            <a:srgbClr val="EFF7F7"/>
+          </a:solidFill>
+          <a:ln/>
+        </p:spPr>
+      </p:sp>
+      <p:sp>
+        <p:nvSpPr>
+          <p:cNvPr id="26" name="Shape 23"/>
+          <p:cNvSpPr/>
+          <p:nvPr/>
+        </p:nvSpPr>
+        <p:spPr>
+          <a:xfrm>
+            <a:off x="749808" y="5317236"/>
+            <a:ext cx="475488" cy="475488"/>
+          </a:xfrm>
+          <a:prstGeom prst="ellipse">
+            <a:avLst/>
+          </a:prstGeom>
+          <a:solidFill>
+            <a:srgbClr val="00A896"/>
+          </a:solidFill>
+          <a:ln/>
+        </p:spPr>
+      </p:sp>
+      <p:pic>
+        <p:nvPicPr>
+          <p:cNvPr id="27" name="Image 1" descr="/tmp/claude-0/-home-user-gpa-academy1/adc6e4aa-3b77-57c1-ba92-a8d4ee625c84/scratchpad/pptx_ch3/icons/checklist_white.png">    </p:cNvPr>
+          <p:cNvPicPr>
+            <a:picLocks noChangeAspect="1"/>
+          </p:cNvPicPr>
+          <p:nvPr/>
+        </p:nvPicPr>
+        <p:blipFill>
+          <a:blip r:embed="rId2"/>
+          <a:stretch>
+            <a:fillRect/>
+          </a:stretch>
+        </p:blipFill>
+        <p:spPr>
+          <a:xfrm>
+            <a:off x="854415" y="5421843"/>
+            <a:ext cx="266273" cy="266273"/>
+          </a:xfrm>
+          <a:prstGeom prst="rect">
+            <a:avLst/>
+          </a:prstGeom>
+        </p:spPr>
+      </p:pic>
+      <p:sp>
+        <p:nvSpPr>
+          <p:cNvPr id="28" name="Text 24"/>
+          <p:cNvSpPr txBox="1"/>
+          <p:nvPr/>
+        </p:nvSpPr>
+        <p:spPr>
+          <a:xfrm>
+            <a:off x="1371600" y="5202936"/>
+            <a:ext cx="5029200" cy="256032"/>
+          </a:xfrm>
+          <a:prstGeom prst="rect">
+            <a:avLst/>
+          </a:prstGeom>
+          <a:noFill/>
+          <a:ln/>
+        </p:spPr>
+        <p:txBody>
+          <a:bodyPr wrap="square" lIns="0" tIns="0" rIns="0" bIns="0" rtlCol="0" anchor="ctr"/>
+          <a:lstStyle/>
+          <a:p>
+            <a:pPr indent="0" marL="0">
+              <a:buNone/>
+            </a:pPr>
+            <a:r>
+              <a:rPr lang="en-US" sz="1350" b="1" dirty="0">
+                <a:solidFill>
+                  <a:srgbClr val="013A40"/>
+                </a:solidFill>
+                <a:latin typeface="Cambria" pitchFamily="34" charset="0"/>
+                <a:ea typeface="Cambria" pitchFamily="34" charset="-122"/>
+                <a:cs typeface="Cambria" pitchFamily="34" charset="-120"/>
+              </a:rPr>
+              <a:t>Cada criterio suma 1 punto</a:t>
+            </a:r>
+            <a:endParaRPr lang="en-US" sz="1350" dirty="0"/>
+          </a:p>
+        </p:txBody>
+      </p:sp>
+      <p:sp>
+        <p:nvSpPr>
+          <p:cNvPr id="29" name="Text 25"/>
+          <p:cNvSpPr txBox="1"/>
+          <p:nvPr/>
+        </p:nvSpPr>
+        <p:spPr>
+          <a:xfrm>
+            <a:off x="1371600" y="5477256"/>
+            <a:ext cx="5029200" cy="457200"/>
+          </a:xfrm>
+          <a:prstGeom prst="rect">
+            <a:avLst/>
+          </a:prstGeom>
+          <a:noFill/>
+          <a:ln/>
+        </p:spPr>
+        <p:txBody>
+          <a:bodyPr wrap="square" lIns="0" tIns="0" rIns="0" bIns="0" rtlCol="0" anchor="t"/>
+          <a:lstStyle/>
+          <a:p>
+            <a:pPr indent="0" marL="0">
+              <a:lnSpc>
+                <a:spcPct val="112000"/>
+              </a:lnSpc>
+              <a:buNone/>
+            </a:pPr>
+            <a:r>
+              <a:rPr lang="en-US" sz="1150" dirty="0">
+                <a:solidFill>
+                  <a:srgbClr val="013A40"/>
+                </a:solidFill>
+                <a:latin typeface="Calibri" pitchFamily="34" charset="0"/>
+                <a:ea typeface="Calibri" pitchFamily="34" charset="-122"/>
+                <a:cs typeface="Calibri" pitchFamily="34" charset="-120"/>
+              </a:rPr>
+              <a:t>El puntaje total (0 a 6) se combina con la capacidad funcional y el riesgo del procedimiento para decidir estudios cardiológicos adicionales.</a:t>
+            </a:r>
+            <a:endParaRPr lang="en-US" sz="1150" dirty="0"/>
+          </a:p>
+        </p:txBody>
+      </p:sp>
+      <p:sp>
+        <p:nvSpPr>
+          <p:cNvPr id="30" name="Shape 26"/>
           <p:cNvSpPr/>
           <p:nvPr/>
         </p:nvSpPr>
@@ -22960,7 +23983,7 @@
       </p:sp>
       <p:sp>
         <p:nvSpPr>
-          <p:cNvPr id="26" name="Text 23"/>
+          <p:cNvPr id="31" name="Text 27"/>
           <p:cNvSpPr txBox="1"/>
           <p:nvPr/>
         </p:nvSpPr>
@@ -24060,14 +25083,14 @@
       </p:graphicFrame>
       <p:sp>
         <p:nvSpPr>
-          <p:cNvPr id="28" name="Text 24"/>
+          <p:cNvPr id="33" name="Text 28"/>
           <p:cNvSpPr txBox="1"/>
           <p:nvPr/>
         </p:nvSpPr>
         <p:spPr>
           <a:xfrm>
-            <a:off x="6949440" y="4251960"/>
-            <a:ext cx="4480560" cy="1737360"/>
+            <a:off x="6949440" y="4553712"/>
+            <a:ext cx="4480560" cy="1371600"/>
           </a:xfrm>
           <a:prstGeom prst="rect">
             <a:avLst/>
@@ -24102,7 +25125,7 @@
       </p:sp>
       <p:sp>
         <p:nvSpPr>
-          <p:cNvPr id="29" name="Text 25"/>
+          <p:cNvPr id="34" name="Text 29"/>
           <p:cNvSpPr txBox="1"/>
           <p:nvPr/>
         </p:nvSpPr>
@@ -24141,7 +25164,7 @@
       </p:sp>
       <p:sp>
         <p:nvSpPr>
-          <p:cNvPr id="30" name="Text 26"/>
+          <p:cNvPr id="35" name="Text 30"/>
           <p:cNvSpPr txBox="1"/>
           <p:nvPr/>
         </p:nvSpPr>
@@ -26058,7 +27081,7 @@
         </p:nvSpPr>
         <p:spPr>
           <a:xfrm>
-            <a:off x="548640" y="4251960"/>
+            <a:off x="548640" y="4617720"/>
             <a:ext cx="6675120" cy="457200"/>
           </a:xfrm>
           <a:prstGeom prst="rect">
@@ -26095,6 +27118,153 @@
       <p:sp>
         <p:nvSpPr>
           <p:cNvPr id="9" name="Shape 5"/>
+          <p:cNvSpPr/>
+          <p:nvPr/>
+        </p:nvSpPr>
+        <p:spPr>
+          <a:xfrm>
+            <a:off x="548640" y="5166360"/>
+            <a:ext cx="6675120" cy="914400"/>
+          </a:xfrm>
+          <a:prstGeom prst="roundRect">
+            <a:avLst>
+              <a:gd name="adj" fmla="val 8000"/>
+            </a:avLst>
+          </a:prstGeom>
+          <a:solidFill>
+            <a:srgbClr val="EFF7F7"/>
+          </a:solidFill>
+          <a:ln/>
+        </p:spPr>
+      </p:sp>
+      <p:sp>
+        <p:nvSpPr>
+          <p:cNvPr id="10" name="Shape 6"/>
+          <p:cNvSpPr/>
+          <p:nvPr/>
+        </p:nvSpPr>
+        <p:spPr>
+          <a:xfrm>
+            <a:off x="749808" y="5385816"/>
+            <a:ext cx="475488" cy="475488"/>
+          </a:xfrm>
+          <a:prstGeom prst="ellipse">
+            <a:avLst/>
+          </a:prstGeom>
+          <a:solidFill>
+            <a:srgbClr val="00A896"/>
+          </a:solidFill>
+          <a:ln/>
+        </p:spPr>
+      </p:sp>
+      <p:pic>
+        <p:nvPicPr>
+          <p:cNvPr id="11" name="Image 1" descr="/tmp/claude-0/-home-user-gpa-academy1/adc6e4aa-3b77-57c1-ba92-a8d4ee625c84/scratchpad/pptx_ch3/icons/warning_white.png">    </p:cNvPr>
+          <p:cNvPicPr>
+            <a:picLocks noChangeAspect="1"/>
+          </p:cNvPicPr>
+          <p:nvPr/>
+        </p:nvPicPr>
+        <p:blipFill>
+          <a:blip r:embed="rId2"/>
+          <a:stretch>
+            <a:fillRect/>
+          </a:stretch>
+        </p:blipFill>
+        <p:spPr>
+          <a:xfrm>
+            <a:off x="854415" y="5490423"/>
+            <a:ext cx="266273" cy="266273"/>
+          </a:xfrm>
+          <a:prstGeom prst="rect">
+            <a:avLst/>
+          </a:prstGeom>
+        </p:spPr>
+      </p:pic>
+      <p:sp>
+        <p:nvSpPr>
+          <p:cNvPr id="12" name="Text 7"/>
+          <p:cNvSpPr txBox="1"/>
+          <p:nvPr/>
+        </p:nvSpPr>
+        <p:spPr>
+          <a:xfrm>
+            <a:off x="1371600" y="5294376"/>
+            <a:ext cx="5669280" cy="256032"/>
+          </a:xfrm>
+          <a:prstGeom prst="rect">
+            <a:avLst/>
+          </a:prstGeom>
+          <a:noFill/>
+          <a:ln/>
+        </p:spPr>
+        <p:txBody>
+          <a:bodyPr wrap="square" lIns="0" tIns="0" rIns="0" bIns="0" rtlCol="0" anchor="ctr"/>
+          <a:lstStyle/>
+          <a:p>
+            <a:pPr indent="0" marL="0">
+              <a:buNone/>
+            </a:pPr>
+            <a:r>
+              <a:rPr lang="en-US" sz="1350" b="1" dirty="0">
+                <a:solidFill>
+                  <a:srgbClr val="013A40"/>
+                </a:solidFill>
+                <a:latin typeface="Cambria" pitchFamily="34" charset="0"/>
+                <a:ea typeface="Cambria" pitchFamily="34" charset="-122"/>
+                <a:cs typeface="Cambria" pitchFamily="34" charset="-120"/>
+              </a:rPr>
+              <a:t>Score MELD</a:t>
+            </a:r>
+            <a:endParaRPr lang="en-US" sz="1350" dirty="0"/>
+          </a:p>
+        </p:txBody>
+      </p:sp>
+      <p:sp>
+        <p:nvSpPr>
+          <p:cNvPr id="13" name="Text 8"/>
+          <p:cNvSpPr txBox="1"/>
+          <p:nvPr/>
+        </p:nvSpPr>
+        <p:spPr>
+          <a:xfrm>
+            <a:off x="1371600" y="5568696"/>
+            <a:ext cx="5669280" cy="411480"/>
+          </a:xfrm>
+          <a:prstGeom prst="rect">
+            <a:avLst/>
+          </a:prstGeom>
+          <a:noFill/>
+          <a:ln/>
+        </p:spPr>
+        <p:txBody>
+          <a:bodyPr wrap="square" lIns="0" tIns="0" rIns="0" bIns="0" rtlCol="0" anchor="t"/>
+          <a:lstStyle/>
+          <a:p>
+            <a:pPr indent="0" marL="0">
+              <a:lnSpc>
+                <a:spcPct val="112000"/>
+              </a:lnSpc>
+              <a:buNone/>
+            </a:pPr>
+            <a:r>
+              <a:rPr lang="en-US" sz="1150" dirty="0">
+                <a:solidFill>
+                  <a:srgbClr val="013A40"/>
+                </a:solidFill>
+                <a:latin typeface="Calibri" pitchFamily="34" charset="0"/>
+                <a:ea typeface="Calibri" pitchFamily="34" charset="-122"/>
+                <a:cs typeface="Calibri" pitchFamily="34" charset="-120"/>
+              </a:rPr>
+              <a:t>En candidatos a trasplante o cirugía de muy alto riesgo, el score MELD (bilirrubina, INR, creatinina) complementa a Child-Pugh con mayor precisión pronóstica.</a:t>
+            </a:r>
+            <a:endParaRPr lang="en-US" sz="1150" dirty="0"/>
+          </a:p>
+        </p:txBody>
+      </p:sp>
+      <p:sp>
+        <p:nvSpPr>
+          <p:cNvPr id="14" name="Shape 9"/>
           <p:cNvSpPr/>
           <p:nvPr/>
         </p:nvSpPr>
@@ -26128,7 +27298,7 @@
       </p:sp>
       <p:sp>
         <p:nvSpPr>
-          <p:cNvPr id="10" name="Text 6"/>
+          <p:cNvPr id="15" name="Text 10"/>
           <p:cNvSpPr txBox="1"/>
           <p:nvPr/>
         </p:nvSpPr>
@@ -26167,7 +27337,7 @@
       </p:sp>
       <p:sp>
         <p:nvSpPr>
-          <p:cNvPr id="11" name="Text 7"/>
+          <p:cNvPr id="16" name="Text 11"/>
           <p:cNvSpPr txBox="1"/>
           <p:nvPr/>
         </p:nvSpPr>
@@ -26291,7 +27461,7 @@
       </p:sp>
       <p:sp>
         <p:nvSpPr>
-          <p:cNvPr id="12" name="Text 8"/>
+          <p:cNvPr id="17" name="Text 12"/>
           <p:cNvSpPr txBox="1"/>
           <p:nvPr/>
         </p:nvSpPr>
@@ -26330,7 +27500,7 @@
       </p:sp>
       <p:sp>
         <p:nvSpPr>
-          <p:cNvPr id="13" name="Text 9"/>
+          <p:cNvPr id="18" name="Text 13"/>
           <p:cNvSpPr txBox="1"/>
           <p:nvPr/>
         </p:nvSpPr>
@@ -27876,14 +29046,80 @@
       </p:sp>
       <p:sp>
         <p:nvSpPr>
-          <p:cNvPr id="26" name="Text 19"/>
+          <p:cNvPr id="26" name="Shape 19"/>
+          <p:cNvSpPr/>
+          <p:nvPr/>
+        </p:nvSpPr>
+        <p:spPr>
+          <a:xfrm>
+            <a:off x="548640" y="5257800"/>
+            <a:ext cx="11064240" cy="960120"/>
+          </a:xfrm>
+          <a:prstGeom prst="roundRect">
+            <a:avLst>
+              <a:gd name="adj" fmla="val 7619"/>
+            </a:avLst>
+          </a:prstGeom>
+          <a:solidFill>
+            <a:srgbClr val="EFF7F7"/>
+          </a:solidFill>
+          <a:ln/>
+        </p:spPr>
+      </p:sp>
+      <p:sp>
+        <p:nvSpPr>
+          <p:cNvPr id="27" name="Shape 20"/>
+          <p:cNvSpPr/>
+          <p:nvPr/>
+        </p:nvSpPr>
+        <p:spPr>
+          <a:xfrm>
+            <a:off x="749808" y="5500116"/>
+            <a:ext cx="475488" cy="475488"/>
+          </a:xfrm>
+          <a:prstGeom prst="ellipse">
+            <a:avLst/>
+          </a:prstGeom>
+          <a:solidFill>
+            <a:srgbClr val="028090"/>
+          </a:solidFill>
+          <a:ln/>
+        </p:spPr>
+      </p:sp>
+      <p:pic>
+        <p:nvPicPr>
+          <p:cNvPr id="28" name="Image 5" descr="/tmp/claude-0/-home-user-gpa-academy1/adc6e4aa-3b77-57c1-ba92-a8d4ee625c84/scratchpad/pptx_ch3/icons/checklist_white.png">    </p:cNvPr>
+          <p:cNvPicPr>
+            <a:picLocks noChangeAspect="1"/>
+          </p:cNvPicPr>
+          <p:nvPr/>
+        </p:nvPicPr>
+        <p:blipFill>
+          <a:blip r:embed="rId6"/>
+          <a:stretch>
+            <a:fillRect/>
+          </a:stretch>
+        </p:blipFill>
+        <p:spPr>
+          <a:xfrm>
+            <a:off x="854415" y="5604723"/>
+            <a:ext cx="266273" cy="266273"/>
+          </a:xfrm>
+          <a:prstGeom prst="rect">
+            <a:avLst/>
+          </a:prstGeom>
+        </p:spPr>
+      </p:pic>
+      <p:sp>
+        <p:nvSpPr>
+          <p:cNvPr id="29" name="Text 21"/>
           <p:cNvSpPr txBox="1"/>
           <p:nvPr/>
         </p:nvSpPr>
         <p:spPr>
           <a:xfrm>
-            <a:off x="548640" y="6528816"/>
-            <a:ext cx="6400800" cy="256032"/>
+            <a:off x="1371600" y="5385816"/>
+            <a:ext cx="10058400" cy="256032"/>
           </a:xfrm>
           <a:prstGeom prst="rect">
             <a:avLst/>
@@ -27899,14 +29135,95 @@
               <a:buNone/>
             </a:pPr>
             <a:r>
-              <a:rPr lang="en-US" sz="900" dirty="0">
-                <a:solidFill>
-                  <a:srgbClr val="90A5A7"/>
+              <a:rPr lang="en-US" sz="1350" b="1" dirty="0">
+                <a:solidFill>
+                  <a:srgbClr val="013A40"/>
+                </a:solidFill>
+                <a:latin typeface="Cambria" pitchFamily="34" charset="0"/>
+                <a:ea typeface="Cambria" pitchFamily="34" charset="-122"/>
+                <a:cs typeface="Cambria" pitchFamily="34" charset="-120"/>
+              </a:rPr>
+              <a:t>Prevención de la retención urinaria postoperatoria</a:t>
+            </a:r>
+            <a:endParaRPr lang="en-US" sz="1350" dirty="0"/>
+          </a:p>
+        </p:txBody>
+      </p:sp>
+      <p:sp>
+        <p:nvSpPr>
+          <p:cNvPr id="30" name="Text 22"/>
+          <p:cNvSpPr txBox="1"/>
+          <p:nvPr/>
+        </p:nvSpPr>
+        <p:spPr>
+          <a:xfrm>
+            <a:off x="1371600" y="5660136"/>
+            <a:ext cx="10058400" cy="457200"/>
+          </a:xfrm>
+          <a:prstGeom prst="rect">
+            <a:avLst/>
+          </a:prstGeom>
+          <a:noFill/>
+          <a:ln/>
+        </p:spPr>
+        <p:txBody>
+          <a:bodyPr wrap="square" lIns="0" tIns="0" rIns="0" bIns="0" rtlCol="0" anchor="t"/>
+          <a:lstStyle/>
+          <a:p>
+            <a:pPr indent="0" marL="0">
+              <a:lnSpc>
+                <a:spcPct val="112000"/>
+              </a:lnSpc>
+              <a:buNone/>
+            </a:pPr>
+            <a:r>
+              <a:rPr lang="en-US" sz="1150" dirty="0">
+                <a:solidFill>
+                  <a:srgbClr val="013A40"/>
                 </a:solidFill>
                 <a:latin typeface="Calibri" pitchFamily="34" charset="0"/>
                 <a:ea typeface="Calibri" pitchFamily="34" charset="-122"/>
                 <a:cs typeface="Calibri" pitchFamily="34" charset="-120"/>
               </a:rPr>
+              <a:t>Limitar la fluidoterapia excesiva, favorecer la deambulación temprana y considerar sondaje profiláctico en procedimientos de alto riesgo (pélvicos, neuroaxiales prolongados), retirando el catéter tan pronto sea posible.</a:t>
+            </a:r>
+            <a:endParaRPr lang="en-US" sz="1150" dirty="0"/>
+          </a:p>
+        </p:txBody>
+      </p:sp>
+      <p:sp>
+        <p:nvSpPr>
+          <p:cNvPr id="31" name="Text 23"/>
+          <p:cNvSpPr txBox="1"/>
+          <p:nvPr/>
+        </p:nvSpPr>
+        <p:spPr>
+          <a:xfrm>
+            <a:off x="548640" y="6528816"/>
+            <a:ext cx="6400800" cy="256032"/>
+          </a:xfrm>
+          <a:prstGeom prst="rect">
+            <a:avLst/>
+          </a:prstGeom>
+          <a:noFill/>
+          <a:ln/>
+        </p:spPr>
+        <p:txBody>
+          <a:bodyPr wrap="square" lIns="0" tIns="0" rIns="0" bIns="0" rtlCol="0" anchor="ctr"/>
+          <a:lstStyle/>
+          <a:p>
+            <a:pPr indent="0" marL="0">
+              <a:buNone/>
+            </a:pPr>
+            <a:r>
+              <a:rPr lang="en-US" sz="900" dirty="0">
+                <a:solidFill>
+                  <a:srgbClr val="90A5A7"/>
+                </a:solidFill>
+                <a:latin typeface="Calibri" pitchFamily="34" charset="0"/>
+                <a:ea typeface="Calibri" pitchFamily="34" charset="-122"/>
+                <a:cs typeface="Calibri" pitchFamily="34" charset="-120"/>
+              </a:rPr>
               <a:t>Capítulo III  ·  Evaluación Preanestésica</a:t>
             </a:r>
             <a:endParaRPr lang="en-US" sz="900" dirty="0"/>
@@ -27915,7 +29232,7 @@
       </p:sp>
       <p:sp>
         <p:nvSpPr>
-          <p:cNvPr id="27" name="Text 20"/>
+          <p:cNvPr id="32" name="Text 24"/>
           <p:cNvSpPr txBox="1"/>
           <p:nvPr/>
         </p:nvSpPr>
@@ -32921,7 +34238,7 @@
         <p:spPr>
           <a:xfrm>
             <a:off x="548640" y="1572768"/>
-            <a:ext cx="7315200" cy="274320"/>
+            <a:ext cx="6217920" cy="274320"/>
           </a:xfrm>
           <a:prstGeom prst="rect">
             <a:avLst/>
@@ -32937,7 +34254,7 @@
               <a:buNone/>
             </a:pPr>
             <a:r>
-              <a:rPr lang="en-US" sz="1300" b="1" spc="50" kern="0" dirty="0">
+              <a:rPr lang="en-US" sz="1250" b="1" spc="50" kern="0" dirty="0">
                 <a:solidFill>
                   <a:srgbClr val="028090"/>
                 </a:solidFill>
@@ -32945,9 +34262,9 @@
                 <a:ea typeface="Calibri" pitchFamily="34" charset="-122"/>
                 <a:cs typeface="Calibri" pitchFamily="34" charset="-120"/>
               </a:rPr>
-              <a:t>GUÍA DE AYUNO PREOPERATORIO (PACIENTE SANO, CIRUGÍA ELECTIVA)</a:t>
-            </a:r>
-            <a:endParaRPr lang="en-US" sz="1300" dirty="0"/>
+              <a:t>GUÍA DE AYUNO PREOPERATORIO (PACIENTE SANO)</a:t>
+            </a:r>
+            <a:endParaRPr lang="en-US" sz="1250" dirty="0"/>
           </a:p>
         </p:txBody>
       </p:sp>
@@ -34058,12 +35375,12 @@
         </p:nvSpPr>
         <p:spPr>
           <a:xfrm>
-            <a:off x="548640" y="4709160"/>
-            <a:ext cx="11064240" cy="1234440"/>
+            <a:off x="548640" y="4892040"/>
+            <a:ext cx="11064240" cy="1188720"/>
           </a:xfrm>
           <a:prstGeom prst="roundRect">
             <a:avLst>
-              <a:gd name="adj" fmla="val 5926"/>
+              <a:gd name="adj" fmla="val 6154"/>
             </a:avLst>
           </a:prstGeom>
           <a:solidFill>
@@ -34080,7 +35397,7 @@
         </p:nvSpPr>
         <p:spPr>
           <a:xfrm>
-            <a:off x="749808" y="5088636"/>
+            <a:off x="749808" y="5248656"/>
             <a:ext cx="475488" cy="475488"/>
           </a:xfrm>
           <a:prstGeom prst="ellipse">
@@ -34108,7 +35425,7 @@
         </p:blipFill>
         <p:spPr>
           <a:xfrm>
-            <a:off x="854415" y="5193243"/>
+            <a:off x="854415" y="5353263"/>
             <a:ext cx="266273" cy="266273"/>
           </a:xfrm>
           <a:prstGeom prst="rect">
@@ -34124,7 +35441,7 @@
         </p:nvSpPr>
         <p:spPr>
           <a:xfrm>
-            <a:off x="1371600" y="4837176"/>
+            <a:off x="1371600" y="5020056"/>
             <a:ext cx="10058400" cy="256032"/>
           </a:xfrm>
           <a:prstGeom prst="rect">
@@ -34163,8 +35480,8 @@
         </p:nvSpPr>
         <p:spPr>
           <a:xfrm>
-            <a:off x="1371600" y="5111496"/>
-            <a:ext cx="10058400" cy="731520"/>
+            <a:off x="1371600" y="5294376"/>
+            <a:ext cx="10058400" cy="685800"/>
           </a:xfrm>
           <a:prstGeom prst="rect">
             <a:avLst/>
@@ -35880,7 +37197,7 @@
         <p:spPr>
           <a:xfrm>
             <a:off x="685800" y="1691640"/>
-            <a:ext cx="2926080" cy="777240"/>
+            <a:ext cx="2926080" cy="566928"/>
           </a:xfrm>
           <a:prstGeom prst="rect">
             <a:avLst/>
@@ -35918,8 +37235,8 @@
         </p:nvSpPr>
         <p:spPr>
           <a:xfrm>
-            <a:off x="685800" y="2501798"/>
-            <a:ext cx="2926080" cy="274320"/>
+            <a:off x="685800" y="2313432"/>
+            <a:ext cx="2926080" cy="256032"/>
           </a:xfrm>
           <a:prstGeom prst="rect">
             <a:avLst/>
@@ -35957,8 +37274,8 @@
         </p:nvSpPr>
         <p:spPr>
           <a:xfrm>
-            <a:off x="685800" y="2757830"/>
-            <a:ext cx="2926080" cy="466344"/>
+            <a:off x="685800" y="2587752"/>
+            <a:ext cx="2926080" cy="438912"/>
           </a:xfrm>
           <a:prstGeom prst="rect">
             <a:avLst/>
@@ -36034,7 +37351,7 @@
         <p:spPr>
           <a:xfrm>
             <a:off x="4069080" y="1691640"/>
-            <a:ext cx="2926080" cy="777240"/>
+            <a:ext cx="2926080" cy="566928"/>
           </a:xfrm>
           <a:prstGeom prst="rect">
             <a:avLst/>
@@ -36072,8 +37389,8 @@
         </p:nvSpPr>
         <p:spPr>
           <a:xfrm>
-            <a:off x="4069080" y="2501798"/>
-            <a:ext cx="2926080" cy="274320"/>
+            <a:off x="4069080" y="2313432"/>
+            <a:ext cx="2926080" cy="256032"/>
           </a:xfrm>
           <a:prstGeom prst="rect">
             <a:avLst/>
@@ -36111,8 +37428,8 @@
         </p:nvSpPr>
         <p:spPr>
           <a:xfrm>
-            <a:off x="4069080" y="2757830"/>
-            <a:ext cx="2926080" cy="466344"/>
+            <a:off x="4069080" y="2587752"/>
+            <a:ext cx="2926080" cy="438912"/>
           </a:xfrm>
           <a:prstGeom prst="rect">
             <a:avLst/>
@@ -36188,7 +37505,7 @@
         <p:spPr>
           <a:xfrm>
             <a:off x="7452360" y="1691640"/>
-            <a:ext cx="3703320" cy="777240"/>
+            <a:ext cx="3703320" cy="566928"/>
           </a:xfrm>
           <a:prstGeom prst="rect">
             <a:avLst/>
@@ -36226,8 +37543,8 @@
         </p:nvSpPr>
         <p:spPr>
           <a:xfrm>
-            <a:off x="7452360" y="2501798"/>
-            <a:ext cx="3703320" cy="274320"/>
+            <a:off x="7452360" y="2313432"/>
+            <a:ext cx="3703320" cy="256032"/>
           </a:xfrm>
           <a:prstGeom prst="rect">
             <a:avLst/>
@@ -36265,8 +37582,8 @@
         </p:nvSpPr>
         <p:spPr>
           <a:xfrm>
-            <a:off x="7452360" y="2757830"/>
-            <a:ext cx="3703320" cy="466344"/>
+            <a:off x="7452360" y="2587752"/>
+            <a:ext cx="3703320" cy="438912"/>
           </a:xfrm>
           <a:prstGeom prst="rect">
             <a:avLst/>
@@ -36346,7 +37663,7 @@
         </p:nvSpPr>
         <p:spPr>
           <a:xfrm>
-            <a:off x="548640" y="3703320"/>
+            <a:off x="548640" y="3730752"/>
             <a:ext cx="10881360" cy="0"/>
           </a:xfrm>
           <a:prstGeom prst="rect">
@@ -36361,13 +37678,13 @@
           <a:p>
             <a:pPr marL="342900" indent="-342900">
               <a:spcAft>
-                <a:spcPts val="800"/>
+                <a:spcPts val="1200"/>
               </a:spcAft>
               <a:buSzPct val="100000"/>
               <a:buChar char="•"/>
             </a:pPr>
             <a:r>
-              <a:rPr lang="en-US" sz="1250" dirty="0">
+              <a:rPr lang="en-US" sz="1300" dirty="0">
                 <a:solidFill>
                   <a:srgbClr val="1B2E30"/>
                 </a:solidFill>
@@ -36377,18 +37694,18 @@
               </a:rPr>
               <a:t>Identificación temprana de vía aérea difícil, cardiopatía no compensada o trastornos de coagulación que modifican la técnica anestésica.</a:t>
             </a:r>
-            <a:endParaRPr lang="en-US" sz="1250" dirty="0"/>
+            <a:endParaRPr lang="en-US" sz="1300" dirty="0"/>
           </a:p>
           <a:p>
             <a:pPr marL="342900" indent="-342900">
               <a:spcAft>
-                <a:spcPts val="800"/>
+                <a:spcPts val="1200"/>
               </a:spcAft>
               <a:buSzPct val="100000"/>
               <a:buChar char="•"/>
             </a:pPr>
             <a:r>
-              <a:rPr lang="en-US" sz="1250" dirty="0">
+              <a:rPr lang="en-US" sz="1300" dirty="0">
                 <a:solidFill>
                   <a:srgbClr val="1B2E30"/>
                 </a:solidFill>
@@ -36398,18 +37715,18 @@
               </a:rPr>
               <a:t>Racionalización de estudios de laboratorio y gabinete, evitando pruebas innecesarias sin valor predictivo para el procedimiento.</a:t>
             </a:r>
-            <a:endParaRPr lang="en-US" sz="1250" dirty="0"/>
+            <a:endParaRPr lang="en-US" sz="1300" dirty="0"/>
           </a:p>
           <a:p>
             <a:pPr marL="342900" indent="-342900">
               <a:spcAft>
-                <a:spcPts val="800"/>
+                <a:spcPts val="1200"/>
               </a:spcAft>
               <a:buSzPct val="100000"/>
               <a:buChar char="•"/>
             </a:pPr>
             <a:r>
-              <a:rPr lang="en-US" sz="1250" dirty="0">
+              <a:rPr lang="en-US" sz="1300" dirty="0">
                 <a:solidFill>
                   <a:srgbClr val="1B2E30"/>
                 </a:solidFill>
@@ -36419,7 +37736,7 @@
               </a:rPr>
               <a:t>Disminución de la ansiedad del paciente mediante información clara sobre el proceso anestésico-quirúrgico.</a:t>
             </a:r>
-            <a:endParaRPr lang="en-US" sz="1250" dirty="0"/>
+            <a:endParaRPr lang="en-US" sz="1300" dirty="0"/>
           </a:p>
           <a:p>
             <a:pPr marL="342900" indent="-342900">
@@ -36427,7 +37744,7 @@
               <a:buChar char="•"/>
             </a:pPr>
             <a:r>
-              <a:rPr lang="en-US" sz="1250" dirty="0">
+              <a:rPr lang="en-US" sz="1300" dirty="0">
                 <a:solidFill>
                   <a:srgbClr val="1B2E30"/>
                 </a:solidFill>
@@ -36437,20 +37754,86 @@
               </a:rPr>
               <a:t>Coordinación oportuna con otras especialidades (cardiología, neumología, hematología) cuando se requiere optimización.</a:t>
             </a:r>
-            <a:endParaRPr lang="en-US" sz="1250" dirty="0"/>
-          </a:p>
-        </p:txBody>
-      </p:sp>
-      <p:sp>
-        <p:nvSpPr>
-          <p:cNvPr id="20" name="Text 17"/>
+            <a:endParaRPr lang="en-US" sz="1300" dirty="0"/>
+          </a:p>
+        </p:txBody>
+      </p:sp>
+      <p:sp>
+        <p:nvSpPr>
+          <p:cNvPr id="20" name="Shape 17"/>
+          <p:cNvSpPr/>
+          <p:nvPr/>
+        </p:nvSpPr>
+        <p:spPr>
+          <a:xfrm>
+            <a:off x="548640" y="5486400"/>
+            <a:ext cx="11064240" cy="868680"/>
+          </a:xfrm>
+          <a:prstGeom prst="roundRect">
+            <a:avLst>
+              <a:gd name="adj" fmla="val 8421"/>
+            </a:avLst>
+          </a:prstGeom>
+          <a:solidFill>
+            <a:srgbClr val="EFF7F7"/>
+          </a:solidFill>
+          <a:ln/>
+        </p:spPr>
+      </p:sp>
+      <p:sp>
+        <p:nvSpPr>
+          <p:cNvPr id="21" name="Shape 18"/>
+          <p:cNvSpPr/>
+          <p:nvPr/>
+        </p:nvSpPr>
+        <p:spPr>
+          <a:xfrm>
+            <a:off x="749808" y="5682996"/>
+            <a:ext cx="475488" cy="475488"/>
+          </a:xfrm>
+          <a:prstGeom prst="ellipse">
+            <a:avLst/>
+          </a:prstGeom>
+          <a:solidFill>
+            <a:srgbClr val="028090"/>
+          </a:solidFill>
+          <a:ln/>
+        </p:spPr>
+      </p:sp>
+      <p:pic>
+        <p:nvPicPr>
+          <p:cNvPr id="22" name="Image 1" descr="/tmp/claude-0/-home-user-gpa-academy1/adc6e4aa-3b77-57c1-ba92-a8d4ee625c84/scratchpad/pptx_ch3/icons/target_white.png">    </p:cNvPr>
+          <p:cNvPicPr>
+            <a:picLocks noChangeAspect="1"/>
+          </p:cNvPicPr>
+          <p:nvPr/>
+        </p:nvPicPr>
+        <p:blipFill>
+          <a:blip r:embed="rId2"/>
+          <a:stretch>
+            <a:fillRect/>
+          </a:stretch>
+        </p:blipFill>
+        <p:spPr>
+          <a:xfrm>
+            <a:off x="854415" y="5787603"/>
+            <a:ext cx="266273" cy="266273"/>
+          </a:xfrm>
+          <a:prstGeom prst="rect">
+            <a:avLst/>
+          </a:prstGeom>
+        </p:spPr>
+      </p:pic>
+      <p:sp>
+        <p:nvSpPr>
+          <p:cNvPr id="23" name="Text 19"/>
           <p:cNvSpPr txBox="1"/>
           <p:nvPr/>
         </p:nvSpPr>
         <p:spPr>
           <a:xfrm>
-            <a:off x="548640" y="6528816"/>
-            <a:ext cx="6400800" cy="256032"/>
+            <a:off x="1371600" y="5614416"/>
+            <a:ext cx="10058400" cy="256032"/>
           </a:xfrm>
           <a:prstGeom prst="rect">
             <a:avLst/>
@@ -36466,14 +37849,95 @@
               <a:buNone/>
             </a:pPr>
             <a:r>
-              <a:rPr lang="en-US" sz="900" dirty="0">
-                <a:solidFill>
-                  <a:srgbClr val="90A5A7"/>
+              <a:rPr lang="en-US" sz="1350" b="1" dirty="0">
+                <a:solidFill>
+                  <a:srgbClr val="013A40"/>
+                </a:solidFill>
+                <a:latin typeface="Cambria" pitchFamily="34" charset="0"/>
+                <a:ea typeface="Cambria" pitchFamily="34" charset="-122"/>
+                <a:cs typeface="Cambria" pitchFamily="34" charset="-120"/>
+              </a:rPr>
+              <a:t>Momento clave</a:t>
+            </a:r>
+            <a:endParaRPr lang="en-US" sz="1350" dirty="0"/>
+          </a:p>
+        </p:txBody>
+      </p:sp>
+      <p:sp>
+        <p:nvSpPr>
+          <p:cNvPr id="24" name="Text 20"/>
+          <p:cNvSpPr txBox="1"/>
+          <p:nvPr/>
+        </p:nvSpPr>
+        <p:spPr>
+          <a:xfrm>
+            <a:off x="1371600" y="5888736"/>
+            <a:ext cx="10058400" cy="365760"/>
+          </a:xfrm>
+          <a:prstGeom prst="rect">
+            <a:avLst/>
+          </a:prstGeom>
+          <a:noFill/>
+          <a:ln/>
+        </p:spPr>
+        <p:txBody>
+          <a:bodyPr wrap="square" lIns="0" tIns="0" rIns="0" bIns="0" rtlCol="0" anchor="t"/>
+          <a:lstStyle/>
+          <a:p>
+            <a:pPr indent="0" marL="0">
+              <a:lnSpc>
+                <a:spcPct val="112000"/>
+              </a:lnSpc>
+              <a:buNone/>
+            </a:pPr>
+            <a:r>
+              <a:rPr lang="en-US" sz="1150" dirty="0">
+                <a:solidFill>
+                  <a:srgbClr val="013A40"/>
                 </a:solidFill>
                 <a:latin typeface="Calibri" pitchFamily="34" charset="0"/>
                 <a:ea typeface="Calibri" pitchFamily="34" charset="-122"/>
                 <a:cs typeface="Calibri" pitchFamily="34" charset="-120"/>
               </a:rPr>
+              <a:t>La consulta preanestésica idealmente ocurre días o semanas antes de la cirugía, no en el preoperatorio inmediato, para permitir optimizar comorbilidades sin retrasar el procedimiento.</a:t>
+            </a:r>
+            <a:endParaRPr lang="en-US" sz="1150" dirty="0"/>
+          </a:p>
+        </p:txBody>
+      </p:sp>
+      <p:sp>
+        <p:nvSpPr>
+          <p:cNvPr id="25" name="Text 21"/>
+          <p:cNvSpPr txBox="1"/>
+          <p:nvPr/>
+        </p:nvSpPr>
+        <p:spPr>
+          <a:xfrm>
+            <a:off x="548640" y="6528816"/>
+            <a:ext cx="6400800" cy="256032"/>
+          </a:xfrm>
+          <a:prstGeom prst="rect">
+            <a:avLst/>
+          </a:prstGeom>
+          <a:noFill/>
+          <a:ln/>
+        </p:spPr>
+        <p:txBody>
+          <a:bodyPr wrap="square" lIns="0" tIns="0" rIns="0" bIns="0" rtlCol="0" anchor="ctr"/>
+          <a:lstStyle/>
+          <a:p>
+            <a:pPr indent="0" marL="0">
+              <a:buNone/>
+            </a:pPr>
+            <a:r>
+              <a:rPr lang="en-US" sz="900" dirty="0">
+                <a:solidFill>
+                  <a:srgbClr val="90A5A7"/>
+                </a:solidFill>
+                <a:latin typeface="Calibri" pitchFamily="34" charset="0"/>
+                <a:ea typeface="Calibri" pitchFamily="34" charset="-122"/>
+                <a:cs typeface="Calibri" pitchFamily="34" charset="-120"/>
+              </a:rPr>
               <a:t>Capítulo III  ·  Evaluación Preanestésica</a:t>
             </a:r>
             <a:endParaRPr lang="en-US" sz="900" dirty="0"/>
@@ -36482,7 +37946,7 @@
       </p:sp>
       <p:sp>
         <p:nvSpPr>
-          <p:cNvPr id="21" name="Text 18"/>
+          <p:cNvPr id="26" name="Text 22"/>
           <p:cNvSpPr txBox="1"/>
           <p:nvPr/>
         </p:nvSpPr>
@@ -39067,14 +40531,80 @@
       </p:sp>
       <p:sp>
         <p:nvSpPr>
-          <p:cNvPr id="25" name="Text 18"/>
+          <p:cNvPr id="25" name="Shape 18"/>
+          <p:cNvSpPr/>
+          <p:nvPr/>
+        </p:nvSpPr>
+        <p:spPr>
+          <a:xfrm>
+            <a:off x="548640" y="4160520"/>
+            <a:ext cx="5394960" cy="1783080"/>
+          </a:xfrm>
+          <a:prstGeom prst="roundRect">
+            <a:avLst>
+              <a:gd name="adj" fmla="val 4103"/>
+            </a:avLst>
+          </a:prstGeom>
+          <a:solidFill>
+            <a:srgbClr val="EFF7F7"/>
+          </a:solidFill>
+          <a:ln/>
+        </p:spPr>
+      </p:sp>
+      <p:sp>
+        <p:nvSpPr>
+          <p:cNvPr id="26" name="Shape 19"/>
+          <p:cNvSpPr/>
+          <p:nvPr/>
+        </p:nvSpPr>
+        <p:spPr>
+          <a:xfrm>
+            <a:off x="749808" y="4814316"/>
+            <a:ext cx="475488" cy="475488"/>
+          </a:xfrm>
+          <a:prstGeom prst="ellipse">
+            <a:avLst/>
+          </a:prstGeom>
+          <a:solidFill>
+            <a:srgbClr val="028090"/>
+          </a:solidFill>
+          <a:ln/>
+        </p:spPr>
+      </p:sp>
+      <p:pic>
+        <p:nvPicPr>
+          <p:cNvPr id="27" name="Image 5" descr="/tmp/claude-0/-home-user-gpa-academy1/adc6e4aa-3b77-57c1-ba92-a8d4ee625c84/scratchpad/pptx_ch3/icons/checklist_white.png">    </p:cNvPr>
+          <p:cNvPicPr>
+            <a:picLocks noChangeAspect="1"/>
+          </p:cNvPicPr>
+          <p:nvPr/>
+        </p:nvPicPr>
+        <p:blipFill>
+          <a:blip r:embed="rId6"/>
+          <a:stretch>
+            <a:fillRect/>
+          </a:stretch>
+        </p:blipFill>
+        <p:spPr>
+          <a:xfrm>
+            <a:off x="854415" y="4918923"/>
+            <a:ext cx="266273" cy="266273"/>
+          </a:xfrm>
+          <a:prstGeom prst="rect">
+            <a:avLst/>
+          </a:prstGeom>
+        </p:spPr>
+      </p:pic>
+      <p:sp>
+        <p:nvSpPr>
+          <p:cNvPr id="28" name="Text 20"/>
           <p:cNvSpPr txBox="1"/>
           <p:nvPr/>
         </p:nvSpPr>
         <p:spPr>
           <a:xfrm>
-            <a:off x="548640" y="6528816"/>
-            <a:ext cx="6400800" cy="256032"/>
+            <a:off x="1371600" y="4288536"/>
+            <a:ext cx="4389120" cy="256032"/>
           </a:xfrm>
           <a:prstGeom prst="rect">
             <a:avLst/>
@@ -39090,14 +40620,95 @@
               <a:buNone/>
             </a:pPr>
             <a:r>
-              <a:rPr lang="en-US" sz="900" dirty="0">
-                <a:solidFill>
-                  <a:srgbClr val="90A5A7"/>
+              <a:rPr lang="en-US" sz="1350" b="1" dirty="0">
+                <a:solidFill>
+                  <a:srgbClr val="013A40"/>
+                </a:solidFill>
+                <a:latin typeface="Cambria" pitchFamily="34" charset="0"/>
+                <a:ea typeface="Cambria" pitchFamily="34" charset="-122"/>
+                <a:cs typeface="Cambria" pitchFamily="34" charset="-120"/>
+              </a:rPr>
+              <a:t>Fuente de mayor confiabilidad</a:t>
+            </a:r>
+            <a:endParaRPr lang="en-US" sz="1350" dirty="0"/>
+          </a:p>
+        </p:txBody>
+      </p:sp>
+      <p:sp>
+        <p:nvSpPr>
+          <p:cNvPr id="29" name="Text 21"/>
+          <p:cNvSpPr txBox="1"/>
+          <p:nvPr/>
+        </p:nvSpPr>
+        <p:spPr>
+          <a:xfrm>
+            <a:off x="1371600" y="4562856"/>
+            <a:ext cx="4389120" cy="1280160"/>
+          </a:xfrm>
+          <a:prstGeom prst="rect">
+            <a:avLst/>
+          </a:prstGeom>
+          <a:noFill/>
+          <a:ln/>
+        </p:spPr>
+        <p:txBody>
+          <a:bodyPr wrap="square" lIns="0" tIns="0" rIns="0" bIns="0" rtlCol="0" anchor="t"/>
+          <a:lstStyle/>
+          <a:p>
+            <a:pPr indent="0" marL="0">
+              <a:lnSpc>
+                <a:spcPct val="112000"/>
+              </a:lnSpc>
+              <a:buNone/>
+            </a:pPr>
+            <a:r>
+              <a:rPr lang="en-US" sz="1150" dirty="0">
+                <a:solidFill>
+                  <a:srgbClr val="013A40"/>
                 </a:solidFill>
                 <a:latin typeface="Calibri" pitchFamily="34" charset="0"/>
                 <a:ea typeface="Calibri" pitchFamily="34" charset="-122"/>
                 <a:cs typeface="Calibri" pitchFamily="34" charset="-120"/>
               </a:rPr>
+              <a:t>Siempre que exista, el expediente o carnet anestésico previo es más confiable que el recuerdo del paciente. Registrar hallazgos relevantes en un formato visible (alerta, brazalete) para el equipo quirúrgico actual.</a:t>
+            </a:r>
+            <a:endParaRPr lang="en-US" sz="1150" dirty="0"/>
+          </a:p>
+        </p:txBody>
+      </p:sp>
+      <p:sp>
+        <p:nvSpPr>
+          <p:cNvPr id="30" name="Text 22"/>
+          <p:cNvSpPr txBox="1"/>
+          <p:nvPr/>
+        </p:nvSpPr>
+        <p:spPr>
+          <a:xfrm>
+            <a:off x="548640" y="6528816"/>
+            <a:ext cx="6400800" cy="256032"/>
+          </a:xfrm>
+          <a:prstGeom prst="rect">
+            <a:avLst/>
+          </a:prstGeom>
+          <a:noFill/>
+          <a:ln/>
+        </p:spPr>
+        <p:txBody>
+          <a:bodyPr wrap="square" lIns="0" tIns="0" rIns="0" bIns="0" rtlCol="0" anchor="ctr"/>
+          <a:lstStyle/>
+          <a:p>
+            <a:pPr indent="0" marL="0">
+              <a:buNone/>
+            </a:pPr>
+            <a:r>
+              <a:rPr lang="en-US" sz="900" dirty="0">
+                <a:solidFill>
+                  <a:srgbClr val="90A5A7"/>
+                </a:solidFill>
+                <a:latin typeface="Calibri" pitchFamily="34" charset="0"/>
+                <a:ea typeface="Calibri" pitchFamily="34" charset="-122"/>
+                <a:cs typeface="Calibri" pitchFamily="34" charset="-120"/>
+              </a:rPr>
               <a:t>Capítulo III  ·  Evaluación Preanestésica</a:t>
             </a:r>
             <a:endParaRPr lang="en-US" sz="900" dirty="0"/>
@@ -39106,7 +40717,7 @@
       </p:sp>
       <p:sp>
         <p:nvSpPr>
-          <p:cNvPr id="26" name="Text 19"/>
+          <p:cNvPr id="31" name="Text 23"/>
           <p:cNvSpPr txBox="1"/>
           <p:nvPr/>
         </p:nvSpPr>
@@ -39629,7 +41240,7 @@
         <p:spPr>
           <a:xfrm>
             <a:off x="7406640" y="2331720"/>
-            <a:ext cx="3703320" cy="868680"/>
+            <a:ext cx="3703320" cy="566928"/>
           </a:xfrm>
           <a:prstGeom prst="rect">
             <a:avLst/>
@@ -39667,8 +41278,8 @@
         </p:nvSpPr>
         <p:spPr>
           <a:xfrm>
-            <a:off x="7406640" y="3247949"/>
-            <a:ext cx="3703320" cy="274320"/>
+            <a:off x="7406640" y="2953512"/>
+            <a:ext cx="3703320" cy="256032"/>
           </a:xfrm>
           <a:prstGeom prst="rect">
             <a:avLst/>
@@ -39706,8 +41317,8 @@
         </p:nvSpPr>
         <p:spPr>
           <a:xfrm>
-            <a:off x="7406640" y="3503981"/>
-            <a:ext cx="3703320" cy="521208"/>
+            <a:off x="7406640" y="3227832"/>
+            <a:ext cx="3703320" cy="621792"/>
           </a:xfrm>
           <a:prstGeom prst="rect">
             <a:avLst/>

</xml_diff>